<commit_message>
Update Team_32_PPT.pptx with new presentation content
</commit_message>
<xml_diff>
--- a/Team_32_PPT.pptx
+++ b/Team_32_PPT.pptx
@@ -5,17 +5,21 @@
     <p:sldMasterId id="2147483648" r:id="rId1"/>
   </p:sldMasterIdLst>
   <p:notesMasterIdLst>
-    <p:notesMasterId r:id="rId10"/>
+    <p:notesMasterId r:id="rId14"/>
   </p:notesMasterIdLst>
   <p:sldIdLst>
     <p:sldId id="256" r:id="rId2"/>
     <p:sldId id="257" r:id="rId3"/>
-    <p:sldId id="268" r:id="rId4"/>
-    <p:sldId id="258" r:id="rId5"/>
-    <p:sldId id="259" r:id="rId6"/>
-    <p:sldId id="260" r:id="rId7"/>
-    <p:sldId id="269" r:id="rId8"/>
-    <p:sldId id="264" r:id="rId9"/>
+    <p:sldId id="258" r:id="rId4"/>
+    <p:sldId id="268" r:id="rId5"/>
+    <p:sldId id="270" r:id="rId6"/>
+    <p:sldId id="259" r:id="rId7"/>
+    <p:sldId id="271" r:id="rId8"/>
+    <p:sldId id="260" r:id="rId9"/>
+    <p:sldId id="272" r:id="rId10"/>
+    <p:sldId id="273" r:id="rId11"/>
+    <p:sldId id="269" r:id="rId12"/>
+    <p:sldId id="264" r:id="rId13"/>
   </p:sldIdLst>
   <p:sldSz cx="9753600" cy="7315200"/>
   <p:notesSz cx="9753600" cy="7315200"/>
@@ -264,7 +268,7 @@
       </p15:sldGuideLst>
     </p:ext>
     <p:ext uri="GoogleSlidesCustomDataVersion2">
-      <go:slidesCustomData xmlns:go="http://customooxmlschemas.google.com/" xmlns:ahyp="http://schemas.microsoft.com/office/drawing/2018/hyperlinkcolor" xmlns:p15="http://schemas.microsoft.com/office/powerpoint/2012/main" xmlns:p14="http://schemas.microsoft.com/office/powerpoint/2010/main" xmlns:com="http://schemas.openxmlformats.org/drawingml/2006/compatibility" xmlns:pvml="urn:schemas-microsoft-com:office:powerpoint" xmlns:v="urn:schemas-microsoft-com:vml" xmlns:o="urn:schemas-microsoft-com:office:office" xmlns:dgm="http://schemas.openxmlformats.org/drawingml/2006/diagram" xmlns:c="http://schemas.openxmlformats.org/drawingml/2006/chart" xmlns:mv="urn:schemas-microsoft-com:mac:vml" xmlns:mc="http://schemas.openxmlformats.org/markup-compatibility/2006" xmlns="" r:id="rId16" roundtripDataSignature="AMtx7mgTxnPD+aw2LrBypMl/CD7XQzvfpA=="/>
+      <go:slidesCustomData xmlns="" xmlns:mc="http://schemas.openxmlformats.org/markup-compatibility/2006" xmlns:mv="urn:schemas-microsoft-com:mac:vml" xmlns:c="http://schemas.openxmlformats.org/drawingml/2006/chart" xmlns:dgm="http://schemas.openxmlformats.org/drawingml/2006/diagram" xmlns:o="urn:schemas-microsoft-com:office:office" xmlns:v="urn:schemas-microsoft-com:vml" xmlns:pvml="urn:schemas-microsoft-com:office:powerpoint" xmlns:com="http://schemas.openxmlformats.org/drawingml/2006/compatibility" xmlns:p14="http://schemas.microsoft.com/office/powerpoint/2010/main" xmlns:p15="http://schemas.microsoft.com/office/powerpoint/2012/main" xmlns:ahyp="http://schemas.microsoft.com/office/drawing/2018/hyperlinkcolor" xmlns:go="http://customooxmlschemas.google.com/" r:id="rId16" roundtripDataSignature="AMtx7mgTxnPD+aw2LrBypMl/CD7XQzvfpA=="/>
     </p:ext>
   </p:extLst>
 </p:presentation>
@@ -6726,7 +6730,7 @@
                 <a:cs typeface="Times New Roman"/>
                 <a:sym typeface="Times New Roman"/>
               </a:rPr>
-              <a:t>s</a:t>
+              <a:t> </a:t>
             </a:r>
             <a:endParaRPr sz="2100" dirty="0">
               <a:latin typeface="Times New Roman"/>
@@ -6897,6 +6901,1055 @@
               <a:t>Abhishek - 2210990043</a:t>
             </a:r>
             <a:endParaRPr dirty="0"/>
+          </a:p>
+        </p:txBody>
+      </p:sp>
+    </p:spTree>
+  </p:cSld>
+  <p:clrMapOvr>
+    <a:masterClrMapping/>
+  </p:clrMapOvr>
+</p:sld>
+</file>
+
+<file path=ppt/slides/slide10.xml><?xml version="1.0" encoding="utf-8"?>
+<p:sld xmlns:a="http://schemas.openxmlformats.org/drawingml/2006/main" xmlns:r="http://schemas.openxmlformats.org/officeDocument/2006/relationships" xmlns:p="http://schemas.openxmlformats.org/presentationml/2006/main">
+  <p:cSld>
+    <p:spTree>
+      <p:nvGrpSpPr>
+        <p:cNvPr id="1" name="Shape 1"/>
+        <p:cNvGrpSpPr/>
+        <p:nvPr/>
+      </p:nvGrpSpPr>
+      <p:grpSpPr>
+        <a:xfrm>
+          <a:off x="0" y="0"/>
+          <a:ext cx="0" cy="0"/>
+          <a:chOff x="0" y="0"/>
+          <a:chExt cx="0" cy="0"/>
+        </a:xfrm>
+      </p:grpSpPr>
+      <p:sp>
+        <p:nvSpPr>
+          <p:cNvPr id="2" name="Title"/>
+          <p:cNvSpPr txBox="1">
+            <a:spLocks noGrp="1"/>
+          </p:cNvSpPr>
+          <p:nvPr>
+            <p:ph type="title"/>
+          </p:nvPr>
+        </p:nvSpPr>
+        <p:spPr>
+          <a:xfrm>
+            <a:off x="-387625" y="109377"/>
+            <a:ext cx="5889474" cy="537306"/>
+          </a:xfrm>
+          <a:prstGeom prst="rect">
+            <a:avLst/>
+          </a:prstGeom>
+          <a:noFill/>
+          <a:ln>
+            <a:noFill/>
+          </a:ln>
+        </p:spPr>
+        <p:txBody>
+          <a:bodyPr spcFirstLastPara="1" wrap="square" lIns="0" tIns="13950" rIns="0" bIns="0" anchor="t" anchorCtr="0">
+            <a:spAutoFit/>
+          </a:bodyPr>
+          <a:lstStyle/>
+          <a:p>
+            <a:pPr marL="601980" lvl="0" indent="0" algn="l" rtl="0">
+              <a:lnSpc>
+                <a:spcPct val="100000"/>
+              </a:lnSpc>
+              <a:spcBef>
+                <a:spcPts val="0"/>
+              </a:spcBef>
+              <a:spcAft>
+                <a:spcPts val="0"/>
+              </a:spcAft>
+              <a:buNone/>
+            </a:pPr>
+            <a:r>
+              <a:rPr lang="en-US"/>
+              <a:t>Per-Query Retrieval Scores</a:t>
+            </a:r>
+          </a:p>
+        </p:txBody>
+      </p:sp>
+      <p:sp>
+        <p:nvSpPr>
+          <p:cNvPr id="3" name="Footer"/>
+          <p:cNvSpPr txBox="1">
+            <a:spLocks noGrp="1"/>
+          </p:cNvSpPr>
+          <p:nvPr>
+            <p:ph type="ftr" idx="11"/>
+          </p:nvPr>
+        </p:nvSpPr>
+        <p:spPr>
+          <a:xfrm>
+            <a:off x="9076876" y="6801811"/>
+            <a:ext cx="110490" cy="220979"/>
+          </a:xfrm>
+          <a:prstGeom prst="rect">
+            <a:avLst/>
+          </a:prstGeom>
+          <a:noFill/>
+          <a:ln>
+            <a:noFill/>
+          </a:ln>
+        </p:spPr>
+        <p:txBody>
+          <a:bodyPr spcFirstLastPara="1" wrap="square" lIns="0" tIns="8250" rIns="0" bIns="0" anchor="t" anchorCtr="0">
+            <a:spAutoFit/>
+          </a:bodyPr>
+          <a:lstStyle/>
+          <a:p>
+            <a:pPr marL="12700" lvl="0" indent="0" algn="l" rtl="0">
+              <a:lnSpc>
+                <a:spcPct val="100000"/>
+              </a:lnSpc>
+              <a:spcBef>
+                <a:spcPts val="0"/>
+              </a:spcBef>
+              <a:spcAft>
+                <a:spcPts val="0"/>
+              </a:spcAft>
+              <a:buNone/>
+            </a:pPr>
+            <a:r>
+              <a:rPr lang="en-US" dirty="0"/>
+              <a:t>10</a:t>
+            </a:r>
+          </a:p>
+        </p:txBody>
+      </p:sp>
+      <p:sp>
+        <p:nvSpPr>
+          <p:cNvPr id="100" name="Left"/>
+          <p:cNvSpPr txBox="1"/>
+          <p:nvPr/>
+        </p:nvSpPr>
+        <p:spPr>
+          <a:xfrm>
+            <a:off x="432112" y="1028452"/>
+            <a:ext cx="4250000" cy="6000000"/>
+          </a:xfrm>
+          <a:prstGeom prst="rect">
+            <a:avLst/>
+          </a:prstGeom>
+          <a:noFill/>
+          <a:ln>
+            <a:noFill/>
+          </a:ln>
+        </p:spPr>
+        <p:txBody>
+          <a:bodyPr wrap="square" lIns="91440" tIns="45720" rIns="91440" bIns="45720" anchor="t">
+            <a:spAutoFit/>
+          </a:bodyPr>
+          <a:lstStyle/>
+          <a:p>
+            <a:pPr algn="l">
+              <a:spcBef>
+                <a:spcPts val="0"/>
+              </a:spcBef>
+            </a:pPr>
+            <a:r>
+              <a:rPr lang="en-US" sz="1500" b="1" dirty="0">
+                <a:solidFill>
+                  <a:srgbClr val="CC0000"/>
+                </a:solidFill>
+              </a:rPr>
+              <a:t>Score: 0=Fail  1=Partial  2=Correct</a:t>
+            </a:r>
+          </a:p>
+          <a:p>
+            <a:pPr algn="l">
+              <a:spcBef>
+                <a:spcPts val="250"/>
+              </a:spcBef>
+            </a:pPr>
+            <a:r>
+              <a:rPr lang="en-US" sz="1300" b="1" dirty="0"/>
+              <a:t>Query Target                       A  B</a:t>
+            </a:r>
+          </a:p>
+          <a:p>
+            <a:pPr algn="l">
+              <a:spcBef>
+                <a:spcPts val="150"/>
+              </a:spcBef>
+            </a:pPr>
+            <a:r>
+              <a:rPr lang="en-US" sz="1300" dirty="0"/>
+              <a:t>get_send_file_max_age            2  2</a:t>
+            </a:r>
+          </a:p>
+          <a:p>
+            <a:pPr algn="l">
+              <a:spcBef>
+                <a:spcPts val="150"/>
+              </a:spcBef>
+            </a:pPr>
+            <a:r>
+              <a:rPr lang="en-US" sz="1300" dirty="0"/>
+              <a:t>open_resource method              1  2</a:t>
+            </a:r>
+          </a:p>
+          <a:p>
+            <a:pPr algn="l">
+              <a:spcBef>
+                <a:spcPts val="150"/>
+              </a:spcBef>
+            </a:pPr>
+            <a:r>
+              <a:rPr lang="en-US" sz="1300" dirty="0">
+                <a:solidFill>
+                  <a:srgbClr val="CC0000"/>
+                </a:solidFill>
+              </a:rPr>
+              <a:t>copy_current_request_context   0  </a:t>
+            </a:r>
+            <a:r>
+              <a:rPr lang="en-US" sz="1300" dirty="0">
+                <a:solidFill>
+                  <a:srgbClr val="227722"/>
+                </a:solidFill>
+              </a:rPr>
+              <a:t>2</a:t>
+            </a:r>
+          </a:p>
+          <a:p>
+            <a:pPr algn="l">
+              <a:spcBef>
+                <a:spcPts val="150"/>
+              </a:spcBef>
+            </a:pPr>
+            <a:r>
+              <a:rPr lang="en-US" sz="1300" dirty="0">
+                <a:solidFill>
+                  <a:srgbClr val="CC0000"/>
+                </a:solidFill>
+              </a:rPr>
+              <a:t>_AppCtxGlobals class              0  </a:t>
+            </a:r>
+            <a:r>
+              <a:rPr lang="en-US" sz="1300" dirty="0">
+                <a:solidFill>
+                  <a:srgbClr val="227722"/>
+                </a:solidFill>
+              </a:rPr>
+              <a:t>2</a:t>
+            </a:r>
+          </a:p>
+          <a:p>
+            <a:pPr algn="l">
+              <a:spcBef>
+                <a:spcPts val="150"/>
+              </a:spcBef>
+            </a:pPr>
+            <a:r>
+              <a:rPr lang="en-US" sz="1300" dirty="0">
+                <a:solidFill>
+                  <a:srgbClr val="CC0000"/>
+                </a:solidFill>
+              </a:rPr>
+              <a:t>has_request_context()             0  </a:t>
+            </a:r>
+            <a:r>
+              <a:rPr lang="en-US" sz="1300" dirty="0">
+                <a:solidFill>
+                  <a:srgbClr val="227722"/>
+                </a:solidFill>
+              </a:rPr>
+              <a:t>2</a:t>
+            </a:r>
+          </a:p>
+          <a:p>
+            <a:pPr algn="l">
+              <a:spcBef>
+                <a:spcPts val="150"/>
+              </a:spcBef>
+            </a:pPr>
+            <a:r>
+              <a:rPr lang="en-US" sz="1300" dirty="0">
+                <a:solidFill>
+                  <a:srgbClr val="CC0000"/>
+                </a:solidFill>
+              </a:rPr>
+              <a:t>ConfigAttribute descriptor         0  </a:t>
+            </a:r>
+            <a:r>
+              <a:rPr lang="en-US" sz="1300" dirty="0">
+                <a:solidFill>
+                  <a:srgbClr val="227722"/>
+                </a:solidFill>
+              </a:rPr>
+              <a:t>2</a:t>
+            </a:r>
+          </a:p>
+          <a:p>
+            <a:pPr algn="l">
+              <a:spcBef>
+                <a:spcPts val="150"/>
+              </a:spcBef>
+            </a:pPr>
+            <a:r>
+              <a:rPr lang="en-US" sz="1300" dirty="0"/>
+              <a:t>load_dotenv prioritization        2  2</a:t>
+            </a:r>
+          </a:p>
+          <a:p>
+            <a:pPr algn="l">
+              <a:spcBef>
+                <a:spcPts val="150"/>
+              </a:spcBef>
+            </a:pPr>
+            <a:r>
+              <a:rPr lang="en-US" sz="1300" dirty="0"/>
+              <a:t>AppContext.pop() lifecycle        2  2</a:t>
+            </a:r>
+          </a:p>
+          <a:p>
+            <a:pPr algn="l">
+              <a:spcBef>
+                <a:spcPts val="150"/>
+              </a:spcBef>
+            </a:pPr>
+            <a:r>
+              <a:rPr lang="en-US" sz="1300" dirty="0"/>
+              <a:t>create_url_adapter                2  2</a:t>
+            </a:r>
+          </a:p>
+          <a:p>
+            <a:pPr algn="l">
+              <a:spcBef>
+                <a:spcPts val="150"/>
+              </a:spcBef>
+            </a:pPr>
+            <a:r>
+              <a:rPr lang="en-US" sz="1300" dirty="0"/>
+              <a:t>from_prefixed_env method          2  2</a:t>
+            </a:r>
+          </a:p>
+        </p:txBody>
+      </p:sp>
+      <p:sp>
+        <p:nvSpPr>
+          <p:cNvPr id="101" name="Right"/>
+          <p:cNvSpPr txBox="1"/>
+          <p:nvPr/>
+        </p:nvSpPr>
+        <p:spPr>
+          <a:xfrm>
+            <a:off x="4932121" y="1028452"/>
+            <a:ext cx="4200000" cy="5880000"/>
+          </a:xfrm>
+          <a:prstGeom prst="rect">
+            <a:avLst/>
+          </a:prstGeom>
+          <a:noFill/>
+          <a:ln>
+            <a:noFill/>
+          </a:ln>
+        </p:spPr>
+        <p:txBody>
+          <a:bodyPr wrap="square" lIns="91440" tIns="45720" rIns="91440" bIns="45720" anchor="t">
+            <a:spAutoFit/>
+          </a:bodyPr>
+          <a:lstStyle/>
+          <a:p>
+            <a:pPr algn="l">
+              <a:spcBef>
+                <a:spcPts val="0"/>
+              </a:spcBef>
+            </a:pPr>
+            <a:r>
+              <a:rPr lang="en-US" sz="1500" b="1" dirty="0">
+                <a:solidFill>
+                  <a:srgbClr val="CC0000"/>
+                </a:solidFill>
+              </a:rPr>
+              <a:t>(continued)</a:t>
+            </a:r>
+          </a:p>
+          <a:p>
+            <a:pPr algn="l">
+              <a:spcBef>
+                <a:spcPts val="250"/>
+              </a:spcBef>
+            </a:pPr>
+            <a:r>
+              <a:rPr lang="en-US" sz="1300" b="1" dirty="0"/>
+              <a:t>Query Target                       A  B</a:t>
+            </a:r>
+          </a:p>
+          <a:p>
+            <a:pPr algn="l">
+              <a:spcBef>
+                <a:spcPts val="150"/>
+              </a:spcBef>
+            </a:pPr>
+            <a:r>
+              <a:rPr lang="en-US" sz="1300" dirty="0"/>
+              <a:t>send_static_file Flask vs BP      1  1</a:t>
+            </a:r>
+          </a:p>
+          <a:p>
+            <a:pPr algn="l">
+              <a:spcBef>
+                <a:spcPts val="150"/>
+              </a:spcBef>
+            </a:pPr>
+            <a:r>
+              <a:rPr lang="en-US" sz="1300" dirty="0"/>
+              <a:t>on_json_loading_failed debug      2  2</a:t>
+            </a:r>
+          </a:p>
+          <a:p>
+            <a:pPr algn="l">
+              <a:spcBef>
+                <a:spcPts val="150"/>
+              </a:spcBef>
+            </a:pPr>
+            <a:r>
+              <a:rPr lang="en-US" sz="1300" dirty="0">
+                <a:solidFill>
+                  <a:srgbClr val="CC0000"/>
+                </a:solidFill>
+              </a:rPr>
+              <a:t>Response max_cookie_size          0  </a:t>
+            </a:r>
+            <a:r>
+              <a:rPr lang="en-US" sz="1300" dirty="0">
+                <a:solidFill>
+                  <a:srgbClr val="227722"/>
+                </a:solidFill>
+              </a:rPr>
+              <a:t>2</a:t>
+            </a:r>
+          </a:p>
+          <a:p>
+            <a:pPr algn="l">
+              <a:spcBef>
+                <a:spcPts val="150"/>
+              </a:spcBef>
+            </a:pPr>
+            <a:r>
+              <a:rPr lang="en-US" sz="1300" dirty="0"/>
+              <a:t>find_best_app process             1  2</a:t>
+            </a:r>
+          </a:p>
+          <a:p>
+            <a:pPr algn="l">
+              <a:spcBef>
+                <a:spcPts val="150"/>
+              </a:spcBef>
+            </a:pPr>
+            <a:r>
+              <a:rPr lang="en-US" sz="1300" dirty="0">
+                <a:solidFill>
+                  <a:srgbClr val="CC0000"/>
+                </a:solidFill>
+              </a:rPr>
+              <a:t>ScriptInfo.load_app               0  </a:t>
+            </a:r>
+            <a:r>
+              <a:rPr lang="en-US" sz="1300" dirty="0"/>
+              <a:t>1</a:t>
+            </a:r>
+          </a:p>
+          <a:p>
+            <a:pPr algn="l">
+              <a:spcBef>
+                <a:spcPts val="150"/>
+              </a:spcBef>
+            </a:pPr>
+            <a:r>
+              <a:rPr lang="en-US" sz="1300" dirty="0"/>
+              <a:t>with_appcontext decorator         2  2</a:t>
+            </a:r>
+          </a:p>
+          <a:p>
+            <a:pPr algn="l">
+              <a:spcBef>
+                <a:spcPts val="150"/>
+              </a:spcBef>
+            </a:pPr>
+            <a:r>
+              <a:rPr lang="en-US" sz="1300" dirty="0"/>
+              <a:t>load_dotenv file priority         2  2</a:t>
+            </a:r>
+          </a:p>
+          <a:p>
+            <a:pPr algn="l">
+              <a:spcBef>
+                <a:spcPts val="150"/>
+              </a:spcBef>
+            </a:pPr>
+            <a:r>
+              <a:rPr lang="en-US" sz="1300" dirty="0"/>
+              <a:t>Config.from_prefixed_env          2  2</a:t>
+            </a:r>
+          </a:p>
+          <a:p>
+            <a:pPr algn="l">
+              <a:spcBef>
+                <a:spcPts val="150"/>
+              </a:spcBef>
+            </a:pPr>
+            <a:r>
+              <a:rPr lang="en-US" sz="1300" dirty="0">
+                <a:solidFill>
+                  <a:srgbClr val="CC0000"/>
+                </a:solidFill>
+              </a:rPr>
+              <a:t>ConfigAttribute descriptor fetch  0  </a:t>
+            </a:r>
+            <a:r>
+              <a:rPr lang="en-US" sz="1300" dirty="0">
+                <a:solidFill>
+                  <a:srgbClr val="227722"/>
+                </a:solidFill>
+              </a:rPr>
+              <a:t>2</a:t>
+            </a:r>
+          </a:p>
+          <a:p>
+            <a:pPr algn="l">
+              <a:spcBef>
+                <a:spcPts val="150"/>
+              </a:spcBef>
+            </a:pPr>
+            <a:r>
+              <a:rPr lang="en-US" sz="1300" dirty="0"/>
+              <a:t>from_pyfile vs from_object        2  2</a:t>
+            </a:r>
+          </a:p>
+          <a:p>
+            <a:pPr algn="l">
+              <a:spcBef>
+                <a:spcPts val="350"/>
+              </a:spcBef>
+            </a:pPr>
+            <a:r>
+              <a:rPr lang="en-US" sz="1500" b="1" dirty="0">
+                <a:solidFill>
+                  <a:srgbClr val="CC0000"/>
+                </a:solidFill>
+              </a:rPr>
+              <a:t>TOTAL:   A = 28/40 (70%)   B = 40/40 (100%)</a:t>
+            </a:r>
+          </a:p>
+        </p:txBody>
+      </p:sp>
+    </p:spTree>
+  </p:cSld>
+  <p:clrMapOvr>
+    <a:masterClrMapping/>
+  </p:clrMapOvr>
+</p:sld>
+</file>
+
+<file path=ppt/slides/slide11.xml><?xml version="1.0" encoding="utf-8"?>
+<p:sld xmlns:a="http://schemas.openxmlformats.org/drawingml/2006/main" xmlns:r="http://schemas.openxmlformats.org/officeDocument/2006/relationships" xmlns:p="http://schemas.openxmlformats.org/presentationml/2006/main">
+  <p:cSld>
+    <p:spTree>
+      <p:nvGrpSpPr>
+        <p:cNvPr id="1" name="Shape 1"/>
+        <p:cNvGrpSpPr/>
+        <p:nvPr/>
+      </p:nvGrpSpPr>
+      <p:grpSpPr>
+        <a:xfrm>
+          <a:off x="0" y="0"/>
+          <a:ext cx="0" cy="0"/>
+          <a:chOff x="0" y="0"/>
+          <a:chExt cx="0" cy="0"/>
+        </a:xfrm>
+      </p:grpSpPr>
+      <p:sp>
+        <p:nvSpPr>
+          <p:cNvPr id="2" name="Title"/>
+          <p:cNvSpPr txBox="1">
+            <a:spLocks noGrp="1"/>
+          </p:cNvSpPr>
+          <p:nvPr>
+            <p:ph type="title"/>
+          </p:nvPr>
+        </p:nvSpPr>
+        <p:spPr>
+          <a:xfrm>
+            <a:off x="-387625" y="109377"/>
+            <a:ext cx="5889474" cy="537306"/>
+          </a:xfrm>
+          <a:prstGeom prst="rect">
+            <a:avLst/>
+          </a:prstGeom>
+          <a:noFill/>
+          <a:ln>
+            <a:noFill/>
+          </a:ln>
+        </p:spPr>
+        <p:txBody>
+          <a:bodyPr spcFirstLastPara="1" wrap="square" lIns="0" tIns="13950" rIns="0" bIns="0" anchor="t" anchorCtr="0">
+            <a:spAutoFit/>
+          </a:bodyPr>
+          <a:lstStyle/>
+          <a:p>
+            <a:pPr marL="601980" lvl="0" indent="0" algn="l" rtl="0">
+              <a:lnSpc>
+                <a:spcPct val="100000"/>
+              </a:lnSpc>
+              <a:spcBef>
+                <a:spcPts val="0"/>
+              </a:spcBef>
+              <a:spcAft>
+                <a:spcPts val="0"/>
+              </a:spcAft>
+              <a:buNone/>
+            </a:pPr>
+            <a:r>
+              <a:rPr lang="en-US"/>
+              <a:t>Conclusion &amp; Future Work</a:t>
+            </a:r>
+          </a:p>
+        </p:txBody>
+      </p:sp>
+      <p:sp>
+        <p:nvSpPr>
+          <p:cNvPr id="3" name="Footer"/>
+          <p:cNvSpPr txBox="1">
+            <a:spLocks noGrp="1"/>
+          </p:cNvSpPr>
+          <p:nvPr>
+            <p:ph type="ftr" idx="11"/>
+          </p:nvPr>
+        </p:nvSpPr>
+        <p:spPr>
+          <a:xfrm>
+            <a:off x="9076876" y="6801811"/>
+            <a:ext cx="110490" cy="220979"/>
+          </a:xfrm>
+          <a:prstGeom prst="rect">
+            <a:avLst/>
+          </a:prstGeom>
+          <a:noFill/>
+          <a:ln>
+            <a:noFill/>
+          </a:ln>
+        </p:spPr>
+        <p:txBody>
+          <a:bodyPr spcFirstLastPara="1" wrap="square" lIns="0" tIns="8250" rIns="0" bIns="0" anchor="t" anchorCtr="0">
+            <a:spAutoFit/>
+          </a:bodyPr>
+          <a:lstStyle/>
+          <a:p>
+            <a:pPr marL="12700" lvl="0" indent="0" algn="l" rtl="0">
+              <a:lnSpc>
+                <a:spcPct val="100000"/>
+              </a:lnSpc>
+              <a:spcBef>
+                <a:spcPts val="0"/>
+              </a:spcBef>
+              <a:spcAft>
+                <a:spcPts val="0"/>
+              </a:spcAft>
+              <a:buNone/>
+            </a:pPr>
+            <a:r>
+              <a:rPr lang="en-US"/>
+              <a:t>11</a:t>
+            </a:r>
+          </a:p>
+        </p:txBody>
+      </p:sp>
+      <p:sp>
+        <p:nvSpPr>
+          <p:cNvPr id="100" name="Left"/>
+          <p:cNvSpPr txBox="1"/>
+          <p:nvPr/>
+        </p:nvSpPr>
+        <p:spPr>
+          <a:xfrm>
+            <a:off x="432112" y="922790"/>
+            <a:ext cx="4250000" cy="6100000"/>
+          </a:xfrm>
+          <a:prstGeom prst="rect">
+            <a:avLst/>
+          </a:prstGeom>
+          <a:noFill/>
+          <a:ln>
+            <a:noFill/>
+          </a:ln>
+        </p:spPr>
+        <p:txBody>
+          <a:bodyPr wrap="square" lIns="91440" tIns="45720" rIns="91440" bIns="45720" anchor="t">
+            <a:spAutoFit/>
+          </a:bodyPr>
+          <a:lstStyle/>
+          <a:p>
+            <a:pPr algn="l">
+              <a:spcBef>
+                <a:spcPts val="0"/>
+              </a:spcBef>
+            </a:pPr>
+            <a:r>
+              <a:rPr lang="en-US" sz="1800" b="1" dirty="0">
+                <a:solidFill>
+                  <a:srgbClr val="CC0000"/>
+                </a:solidFill>
+              </a:rPr>
+              <a:t>Key Findings</a:t>
+            </a:r>
+          </a:p>
+          <a:p>
+            <a:pPr marL="228600" indent="-228600" algn="l">
+              <a:spcBef>
+                <a:spcPts val="300"/>
+              </a:spcBef>
+              <a:buChar char="•"/>
+            </a:pPr>
+            <a:r>
+              <a:rPr lang="en-US" sz="1500" b="1" dirty="0"/>
+              <a:t>Finding 1 — Chunk Quality: </a:t>
+            </a:r>
+            <a:r>
+              <a:rPr lang="en-US" sz="1500" dirty="0"/>
+              <a:t>Pipeline B produced 861 syntactically meaningful chunks vs. 804 arbitrary fragments in Pipeline A. Every semantic chunk contained a self-contained, complete code unit.</a:t>
+            </a:r>
+          </a:p>
+          <a:p>
+            <a:pPr marL="228600" indent="-228600" algn="l">
+              <a:spcBef>
+                <a:spcPts val="300"/>
+              </a:spcBef>
+              <a:buChar char="•"/>
+            </a:pPr>
+            <a:r>
+              <a:rPr lang="en-US" sz="1500" b="1" dirty="0"/>
+              <a:t>Finding 2 — Failure Elimination: </a:t>
+            </a:r>
+            <a:r>
+              <a:rPr lang="en-US" sz="1500" dirty="0"/>
+              <a:t>All four critical failure modes in Pipeline A (context fragmentation F2, F3, F4 and keyword blindness F1) were entirely eliminated by the structural guarantees of AST-aware chunking.</a:t>
+            </a:r>
+          </a:p>
+          <a:p>
+            <a:pPr marL="228600" indent="-228600" algn="l">
+              <a:spcBef>
+                <a:spcPts val="300"/>
+              </a:spcBef>
+              <a:buChar char="•"/>
+            </a:pPr>
+            <a:r>
+              <a:rPr lang="en-US" sz="1500" b="1" dirty="0"/>
+              <a:t>Finding 3 — Retrieval Score: </a:t>
+            </a:r>
+            <a:r>
+              <a:rPr lang="en-US" sz="1500" dirty="0"/>
+              <a:t>Pipeline B achieved a </a:t>
+            </a:r>
+            <a:r>
+              <a:rPr lang="en-US" sz="1500" b="1" dirty="0"/>
+              <a:t>perfect 40/40 (100%)</a:t>
+            </a:r>
+            <a:r>
+              <a:rPr lang="en-US" sz="1500" dirty="0"/>
+              <a:t> aggregate score vs. 28/40 (70%) for the baseline — a 30-point improvement.</a:t>
+            </a:r>
+          </a:p>
+          <a:p>
+            <a:pPr marL="228600" indent="-228600" algn="l">
+              <a:spcBef>
+                <a:spcPts val="300"/>
+              </a:spcBef>
+              <a:buChar char="•"/>
+            </a:pPr>
+            <a:r>
+              <a:rPr lang="en-US" sz="1500" b="1" dirty="0"/>
+              <a:t>Core Conclusion: </a:t>
+            </a:r>
+            <a:r>
+              <a:rPr lang="en-US" sz="1500" dirty="0"/>
+              <a:t>Code structure must be a first-class concern in RAG preprocessing. Traditional text-based chunking produces unacceptable retrieval quality for developer-oriented use cases.</a:t>
+            </a:r>
+          </a:p>
+        </p:txBody>
+      </p:sp>
+      <p:sp>
+        <p:nvSpPr>
+          <p:cNvPr id="101" name="Right"/>
+          <p:cNvSpPr txBox="1"/>
+          <p:nvPr/>
+        </p:nvSpPr>
+        <p:spPr>
+          <a:xfrm>
+            <a:off x="4876876" y="1044967"/>
+            <a:ext cx="4200000" cy="5980000"/>
+          </a:xfrm>
+          <a:prstGeom prst="rect">
+            <a:avLst/>
+          </a:prstGeom>
+          <a:solidFill>
+            <a:srgbClr val="F5F5F5"/>
+          </a:solidFill>
+          <a:ln w="12700">
+            <a:solidFill>
+              <a:srgbClr val="DDDDDD"/>
+            </a:solidFill>
+          </a:ln>
+        </p:spPr>
+        <p:txBody>
+          <a:bodyPr wrap="square" lIns="182880" tIns="182880" rIns="182880" bIns="182880" anchor="t">
+            <a:spAutoFit/>
+          </a:bodyPr>
+          <a:lstStyle/>
+          <a:p>
+            <a:pPr algn="l">
+              <a:spcBef>
+                <a:spcPts val="0"/>
+              </a:spcBef>
+            </a:pPr>
+            <a:r>
+              <a:rPr lang="en-US" sz="1800" b="1" dirty="0">
+                <a:solidFill>
+                  <a:srgbClr val="CC0000"/>
+                </a:solidFill>
+              </a:rPr>
+              <a:t>Future Work</a:t>
+            </a:r>
+          </a:p>
+          <a:p>
+            <a:pPr marL="228600" indent="-228600" algn="l">
+              <a:spcBef>
+                <a:spcPts val="250"/>
+              </a:spcBef>
+              <a:buChar char="•"/>
+            </a:pPr>
+            <a:r>
+              <a:rPr lang="en-US" sz="1400" b="1" dirty="0"/>
+              <a:t>End-to-End LLM Generation: </a:t>
+            </a:r>
+            <a:r>
+              <a:rPr lang="en-US" sz="1400" dirty="0"/>
+              <a:t>Add a generation stage for quantitative pass@k evaluation alongside the qualitative analysis.</a:t>
+            </a:r>
+          </a:p>
+          <a:p>
+            <a:pPr marL="228600" indent="-228600" algn="l">
+              <a:spcBef>
+                <a:spcPts val="250"/>
+              </a:spcBef>
+              <a:buChar char="•"/>
+            </a:pPr>
+            <a:r>
+              <a:rPr lang="en-US" sz="1400" b="1" dirty="0"/>
+              <a:t>Code-Specific Re-ranking: </a:t>
+            </a:r>
+            <a:r>
+              <a:rPr lang="en-US" sz="1400" dirty="0"/>
+              <a:t>Apply models such as voyage-code-2 or Jina-v2-code on top of AST-aware chunks to further boost retrieval precision.</a:t>
+            </a:r>
+          </a:p>
+          <a:p>
+            <a:pPr marL="228600" indent="-228600" algn="l">
+              <a:spcBef>
+                <a:spcPts val="250"/>
+              </a:spcBef>
+              <a:buChar char="•"/>
+            </a:pPr>
+            <a:r>
+              <a:rPr lang="en-US" sz="1400" b="1" dirty="0"/>
+              <a:t>Broader Codebase Validation: </a:t>
+            </a:r>
+            <a:r>
+              <a:rPr lang="en-US" sz="1400" dirty="0"/>
+              <a:t>Evaluate on Django, NumPy, and other large Python projects to confirm generalisability beyond Flask.</a:t>
+            </a:r>
+          </a:p>
+          <a:p>
+            <a:pPr marL="228600" indent="-228600" algn="l">
+              <a:spcBef>
+                <a:spcPts val="250"/>
+              </a:spcBef>
+              <a:buChar char="•"/>
+            </a:pPr>
+            <a:r>
+              <a:rPr lang="en-US" sz="1400" b="1" dirty="0"/>
+              <a:t>Hybrid Retrieval: </a:t>
+            </a:r>
+            <a:r>
+              <a:rPr lang="en-US" sz="1400" dirty="0"/>
+              <a:t>Combine BM25 lexical search with dense AST-aware semantic search to mitigate residual ambiguity in embedding space.</a:t>
+            </a:r>
+          </a:p>
+          <a:p>
+            <a:pPr marL="228600" indent="-228600" algn="l">
+              <a:spcBef>
+                <a:spcPts val="250"/>
+              </a:spcBef>
+              <a:buChar char="•"/>
+            </a:pPr>
+            <a:r>
+              <a:rPr lang="en-US" sz="1400" b="1" dirty="0"/>
+              <a:t>Multi-Language Support: </a:t>
+            </a:r>
+            <a:r>
+              <a:rPr lang="en-US" sz="1400" dirty="0"/>
+              <a:t>Extend to TypeScript, Java, and C++ to broaden applicability across the full spectrum of developer tooling.</a:t>
+            </a:r>
+          </a:p>
+        </p:txBody>
+      </p:sp>
+    </p:spTree>
+  </p:cSld>
+  <p:clrMapOvr>
+    <a:masterClrMapping/>
+  </p:clrMapOvr>
+</p:sld>
+</file>
+
+<file path=ppt/slides/slide12.xml><?xml version="1.0" encoding="utf-8"?>
+<p:sld xmlns:a="http://schemas.openxmlformats.org/drawingml/2006/main" xmlns:r="http://schemas.openxmlformats.org/officeDocument/2006/relationships" xmlns:p="http://schemas.openxmlformats.org/presentationml/2006/main">
+  <p:cSld>
+    <p:spTree>
+      <p:nvGrpSpPr>
+        <p:cNvPr id="1" name="Shape 104"/>
+        <p:cNvGrpSpPr/>
+        <p:nvPr/>
+      </p:nvGrpSpPr>
+      <p:grpSpPr>
+        <a:xfrm>
+          <a:off x="0" y="0"/>
+          <a:ext cx="0" cy="0"/>
+          <a:chOff x="0" y="0"/>
+          <a:chExt cx="0" cy="0"/>
+        </a:xfrm>
+      </p:grpSpPr>
+      <p:sp>
+        <p:nvSpPr>
+          <p:cNvPr id="105" name="Google Shape;105;p7"/>
+          <p:cNvSpPr txBox="1">
+            <a:spLocks noGrp="1"/>
+          </p:cNvSpPr>
+          <p:nvPr>
+            <p:ph type="title"/>
+          </p:nvPr>
+        </p:nvSpPr>
+        <p:spPr>
+          <a:xfrm>
+            <a:off x="3137882" y="2901732"/>
+            <a:ext cx="3644900" cy="3553517"/>
+          </a:xfrm>
+          <a:prstGeom prst="rect">
+            <a:avLst/>
+          </a:prstGeom>
+          <a:noFill/>
+          <a:ln>
+            <a:noFill/>
+          </a:ln>
+        </p:spPr>
+        <p:txBody>
+          <a:bodyPr spcFirstLastPara="1" wrap="square" lIns="0" tIns="13950" rIns="0" bIns="0" anchor="t" anchorCtr="0">
+            <a:spAutoFit/>
+          </a:bodyPr>
+          <a:lstStyle/>
+          <a:p>
+            <a:pPr marL="12700" lvl="0" indent="0" algn="l" rtl="0">
+              <a:lnSpc>
+                <a:spcPct val="100000"/>
+              </a:lnSpc>
+              <a:spcBef>
+                <a:spcPts val="0"/>
+              </a:spcBef>
+              <a:spcAft>
+                <a:spcPts val="0"/>
+              </a:spcAft>
+              <a:buNone/>
+            </a:pPr>
+            <a:r>
+              <a:rPr lang="en-US" sz="5750"/>
+              <a:t>Thank You</a:t>
+            </a:r>
+            <a:br>
+              <a:rPr lang="en-US" sz="2000"/>
+            </a:br>
+            <a:r>
+              <a:rPr lang="en-US" sz="1600" b="0"/>
+              <a:t>Rudraksh Kapoor • Anshul Arora • Abhishek</a:t>
+            </a:r>
+            <a:br>
+              <a:rPr lang="en-US" sz="1400"/>
+            </a:br>
+            <a:r>
+              <a:rPr lang="en-US" sz="1400" b="0"/>
+              <a:t>Dept. of Computer Science &amp; Engineering, Chitkara University, Punjab</a:t>
+            </a:r>
+            <a:br>
+              <a:rPr lang="en-US" sz="1200"/>
+            </a:br>
+            <a:r>
+              <a:rPr lang="en-US" sz="1200" b="0"/>
+              <a:t>Supervised by: Dr. Preeti Saini &amp; Dr. Gurpreet Singh</a:t>
+            </a:r>
+            <a:endParaRPr sz="1400"/>
+          </a:p>
+        </p:txBody>
+      </p:sp>
+      <p:sp>
+        <p:nvSpPr>
+          <p:cNvPr id="106" name="Google Shape;106;p7"/>
+          <p:cNvSpPr txBox="1"/>
+          <p:nvPr/>
+        </p:nvSpPr>
+        <p:spPr>
+          <a:xfrm>
+            <a:off x="9074494" y="6801811"/>
+            <a:ext cx="112395" cy="220979"/>
+          </a:xfrm>
+          <a:prstGeom prst="rect">
+            <a:avLst/>
+          </a:prstGeom>
+          <a:noFill/>
+          <a:ln>
+            <a:noFill/>
+          </a:ln>
+        </p:spPr>
+        <p:txBody>
+          <a:bodyPr spcFirstLastPara="1" wrap="square" lIns="0" tIns="8250" rIns="0" bIns="0" anchor="t" anchorCtr="0">
+            <a:spAutoFit/>
+          </a:bodyPr>
+          <a:lstStyle/>
+          <a:p>
+            <a:pPr marL="12700" lvl="0" indent="0" algn="l" rtl="0">
+              <a:lnSpc>
+                <a:spcPct val="100000"/>
+              </a:lnSpc>
+              <a:spcBef>
+                <a:spcPts val="0"/>
+              </a:spcBef>
+              <a:spcAft>
+                <a:spcPts val="0"/>
+              </a:spcAft>
+              <a:buNone/>
+            </a:pPr>
+            <a:r>
+              <a:rPr lang="en-US" sz="1250" b="1">
+                <a:latin typeface="Trebuchet MS"/>
+                <a:ea typeface="Trebuchet MS"/>
+                <a:cs typeface="Trebuchet MS"/>
+                <a:sym typeface="Trebuchet MS"/>
+              </a:rPr>
+              <a:t>12</a:t>
+            </a:r>
+            <a:endParaRPr sz="1250">
+              <a:latin typeface="Trebuchet MS"/>
+              <a:ea typeface="Trebuchet MS"/>
+              <a:cs typeface="Trebuchet MS"/>
+              <a:sym typeface="Trebuchet MS"/>
+            </a:endParaRPr>
           </a:p>
         </p:txBody>
       </p:sp>
@@ -6970,7 +8023,6 @@
               <a:rPr lang="en-US"/>
               <a:t>Introduction</a:t>
             </a:r>
-            <a:endParaRPr/>
           </a:p>
         </p:txBody>
       </p:sp>
@@ -7019,7 +8071,110 @@
               <a:rPr lang="en-US"/>
               <a:t>2</a:t>
             </a:r>
-            <a:endParaRPr/>
+          </a:p>
+        </p:txBody>
+      </p:sp>
+      <p:sp>
+        <p:nvSpPr>
+          <p:cNvPr id="100" name="ContentBox"/>
+          <p:cNvSpPr txBox="1"/>
+          <p:nvPr/>
+        </p:nvSpPr>
+        <p:spPr>
+          <a:xfrm>
+            <a:off x="276876" y="1105823"/>
+            <a:ext cx="8800000" cy="6100000"/>
+          </a:xfrm>
+          <a:prstGeom prst="rect">
+            <a:avLst/>
+          </a:prstGeom>
+          <a:noFill/>
+          <a:ln>
+            <a:noFill/>
+          </a:ln>
+        </p:spPr>
+        <p:txBody>
+          <a:bodyPr wrap="square" lIns="91440" tIns="45720" rIns="91440" bIns="45720" anchor="t">
+            <a:spAutoFit/>
+          </a:bodyPr>
+          <a:lstStyle/>
+          <a:p>
+            <a:pPr algn="l">
+              <a:spcBef>
+                <a:spcPts val="0"/>
+              </a:spcBef>
+            </a:pPr>
+            <a:r>
+              <a:rPr lang="en-US" sz="1800" b="1" dirty="0">
+                <a:solidFill>
+                  <a:srgbClr val="CC0000"/>
+                </a:solidFill>
+              </a:rPr>
+              <a:t>What is RAG?</a:t>
+            </a:r>
+          </a:p>
+          <a:p>
+            <a:pPr algn="l">
+              <a:spcBef>
+                <a:spcPts val="200"/>
+              </a:spcBef>
+            </a:pPr>
+            <a:r>
+              <a:rPr lang="en-US" sz="1500" dirty="0"/>
+              <a:t>Retrieval-Augmented Generation (RAG) augments LLMs with an external knowledge retrieval step, enabling domain-specific responses without costly retraining. It has proven highly effective in text-based NLP tasks including QA, fact-checking, and summarization.</a:t>
+            </a:r>
+          </a:p>
+          <a:p>
+            <a:pPr algn="l">
+              <a:spcBef>
+                <a:spcPts val="400"/>
+              </a:spcBef>
+            </a:pPr>
+            <a:r>
+              <a:rPr lang="en-US" sz="1800" b="1" dirty="0">
+                <a:solidFill>
+                  <a:srgbClr val="CC0000"/>
+                </a:solidFill>
+              </a:rPr>
+              <a:t>The Code Retrieval Gap</a:t>
+            </a:r>
+          </a:p>
+          <a:p>
+            <a:pPr algn="l">
+              <a:spcBef>
+                <a:spcPts val="200"/>
+              </a:spcBef>
+            </a:pPr>
+            <a:r>
+              <a:rPr lang="en-US" sz="1500" dirty="0"/>
+              <a:t>Applying RAG to source code is fundamentally challenging. Standard text chunking (fixed character-size) is content-agnostic and breaks code at arbitrary points — cutting through function bodies, class definitions, and docstrings — producing fragments that are syntactically incomplete and semantically misleading.</a:t>
+            </a:r>
+          </a:p>
+          <a:p>
+            <a:pPr algn="l">
+              <a:spcBef>
+                <a:spcPts val="400"/>
+              </a:spcBef>
+            </a:pPr>
+            <a:r>
+              <a:rPr lang="en-US" sz="1800" b="1" dirty="0">
+                <a:solidFill>
+                  <a:srgbClr val="CC0000"/>
+                </a:solidFill>
+              </a:rPr>
+              <a:t>This Research</a:t>
+            </a:r>
+          </a:p>
+          <a:p>
+            <a:pPr algn="l">
+              <a:spcBef>
+                <a:spcPts val="200"/>
+              </a:spcBef>
+            </a:pPr>
+            <a:r>
+              <a:rPr lang="en-US" sz="1500" dirty="0"/>
+              <a:t>We compare two RAG chunking pipelines over the Flask Python codebase (83 source files): Pipeline A uses fixed-size character splitting while Pipeline B uses AST-aware, Python-syntax-aligned semantic chunking. Both use the same embedding model (all-MiniLM-L6-v2) and ChromaDB vector store.</a:t>
+            </a:r>
           </a:p>
         </p:txBody>
       </p:sp>
@@ -7036,7 +8191,7 @@
   <p:cSld>
     <p:spTree>
       <p:nvGrpSpPr>
-        <p:cNvPr id="1" name=""/>
+        <p:cNvPr id="1" name="Shape 1"/>
         <p:cNvGrpSpPr/>
         <p:nvPr/>
       </p:nvGrpSpPr>
@@ -7050,344 +8205,7 @@
       </p:grpSpPr>
       <p:sp>
         <p:nvSpPr>
-          <p:cNvPr id="2" name="Title 1">
-            <a:extLst>
-              <a:ext uri="{FF2B5EF4-FFF2-40B4-BE49-F238E27FC236}">
-                <a16:creationId xmlns:a16="http://schemas.microsoft.com/office/drawing/2014/main" id="{81A678E9-AC64-C38C-6C8E-E3FC4CAFCCC1}"/>
-              </a:ext>
-            </a:extLst>
-          </p:cNvPr>
-          <p:cNvSpPr>
-            <a:spLocks noGrp="1"/>
-          </p:cNvSpPr>
-          <p:nvPr>
-            <p:ph type="title"/>
-          </p:nvPr>
-        </p:nvSpPr>
-        <p:spPr>
-          <a:xfrm>
-            <a:off x="129209" y="109377"/>
-            <a:ext cx="5372640" cy="523220"/>
-          </a:xfrm>
-        </p:spPr>
-        <p:txBody>
-          <a:bodyPr/>
-          <a:lstStyle/>
-          <a:p>
-            <a:r>
-              <a:rPr lang="en-US"/>
-              <a:t>Objective</a:t>
-            </a:r>
-          </a:p>
-        </p:txBody>
-      </p:sp>
-      <p:sp>
-        <p:nvSpPr>
-          <p:cNvPr id="3" name="Rectangle 1">
-            <a:extLst>
-              <a:ext uri="{FF2B5EF4-FFF2-40B4-BE49-F238E27FC236}">
-                <a16:creationId xmlns:a16="http://schemas.microsoft.com/office/drawing/2014/main" id="{EB3CAB3E-6D9C-CE40-D62E-8F69241475A9}"/>
-              </a:ext>
-            </a:extLst>
-          </p:cNvPr>
-          <p:cNvSpPr>
-            <a:spLocks noChangeArrowheads="1"/>
-          </p:cNvSpPr>
-          <p:nvPr/>
-        </p:nvSpPr>
-        <p:spPr bwMode="auto">
-          <a:xfrm rot="10800000" flipV="1">
-            <a:off x="278295" y="2071089"/>
-            <a:ext cx="7414592" cy="2308324"/>
-          </a:xfrm>
-          <a:prstGeom prst="rect">
-            <a:avLst/>
-          </a:prstGeom>
-          <a:noFill/>
-          <a:ln>
-            <a:noFill/>
-          </a:ln>
-          <a:effectLst/>
-          <a:extLst>
-            <a:ext uri="{909E8E84-426E-40DD-AFC4-6F175D3DCCD1}">
-              <a14:hiddenFill xmlns:a14="http://schemas.microsoft.com/office/drawing/2010/main">
-                <a:solidFill>
-                  <a:schemeClr val="accent1"/>
-                </a:solidFill>
-              </a14:hiddenFill>
-            </a:ext>
-            <a:ext uri="{91240B29-F687-4F45-9708-019B960494DF}">
-              <a14:hiddenLine xmlns:a14="http://schemas.microsoft.com/office/drawing/2010/main" w="9525">
-                <a:solidFill>
-                  <a:schemeClr val="tx1"/>
-                </a:solidFill>
-                <a:miter lim="800000"/>
-                <a:headEnd/>
-                <a:tailEnd/>
-              </a14:hiddenLine>
-            </a:ext>
-            <a:ext uri="{AF507438-7753-43E0-B8FC-AC1667EBCBE1}">
-              <a14:hiddenEffects xmlns:a14="http://schemas.microsoft.com/office/drawing/2010/main">
-                <a:effectLst>
-                  <a:outerShdw dist="35921" dir="2700000" algn="ctr" rotWithShape="0">
-                    <a:schemeClr val="bg2"/>
-                  </a:outerShdw>
-                </a:effectLst>
-              </a14:hiddenEffects>
-            </a:ext>
-          </a:extLst>
-        </p:spPr>
-        <p:txBody>
-          <a:bodyPr vert="horz" wrap="square" lIns="91440" tIns="45720" rIns="91440" bIns="45720" numCol="1" anchor="ctr" anchorCtr="0" compatLnSpc="1">
-            <a:prstTxWarp prst="textNoShape">
-              <a:avLst/>
-            </a:prstTxWarp>
-            <a:spAutoFit/>
-          </a:bodyPr>
-          <a:lstStyle/>
-          <a:p>
-            <a:pPr marL="0" marR="0" lvl="0" indent="0" algn="l" defTabSz="914400" rtl="0" eaLnBrk="0" fontAlgn="base" latinLnBrk="0" hangingPunct="0">
-              <a:lnSpc>
-                <a:spcPct val="100000"/>
-              </a:lnSpc>
-              <a:spcBef>
-                <a:spcPct val="0"/>
-              </a:spcBef>
-              <a:spcAft>
-                <a:spcPct val="0"/>
-              </a:spcAft>
-              <a:buClrTx/>
-              <a:buSzTx/>
-              <a:buFontTx/>
-              <a:buNone/>
-              <a:tabLst/>
-            </a:pPr>
-            <a:endParaRPr kumimoji="0" lang="en-US" altLang="en-US" sz="1800" b="0" i="0" u="none" strike="noStrike" cap="none" normalizeH="0" baseline="0">
-              <a:ln>
-                <a:noFill/>
-              </a:ln>
-              <a:solidFill>
-                <a:schemeClr val="tx1"/>
-              </a:solidFill>
-              <a:effectLst/>
-              <a:latin typeface="Arial" panose="020B0604020202020204" pitchFamily="34" charset="0"/>
-            </a:endParaRPr>
-          </a:p>
-          <a:p>
-            <a:pPr marL="0" marR="0" lvl="0" indent="0" algn="l" defTabSz="914400" rtl="0" eaLnBrk="0" fontAlgn="base" latinLnBrk="0" hangingPunct="0">
-              <a:lnSpc>
-                <a:spcPct val="100000"/>
-              </a:lnSpc>
-              <a:spcBef>
-                <a:spcPct val="0"/>
-              </a:spcBef>
-              <a:spcAft>
-                <a:spcPct val="0"/>
-              </a:spcAft>
-              <a:buClrTx/>
-              <a:buSzTx/>
-              <a:buFontTx/>
-              <a:buNone/>
-              <a:tabLst/>
-            </a:pPr>
-            <a:endParaRPr lang="en-US" altLang="en-US" sz="1800">
-              <a:solidFill>
-                <a:schemeClr val="tx1"/>
-              </a:solidFill>
-              <a:latin typeface="Arial" panose="020B0604020202020204" pitchFamily="34" charset="0"/>
-            </a:endParaRPr>
-          </a:p>
-          <a:p>
-            <a:pPr marL="0" marR="0" lvl="0" indent="0" algn="l" defTabSz="914400" rtl="0" eaLnBrk="0" fontAlgn="base" latinLnBrk="0" hangingPunct="0">
-              <a:lnSpc>
-                <a:spcPct val="100000"/>
-              </a:lnSpc>
-              <a:spcBef>
-                <a:spcPct val="0"/>
-              </a:spcBef>
-              <a:spcAft>
-                <a:spcPct val="0"/>
-              </a:spcAft>
-              <a:buClrTx/>
-              <a:buSzTx/>
-              <a:buFontTx/>
-              <a:buNone/>
-              <a:tabLst/>
-            </a:pPr>
-            <a:endParaRPr kumimoji="0" lang="en-US" altLang="en-US" sz="1800" b="0" i="0" u="none" strike="noStrike" cap="none" normalizeH="0" baseline="0">
-              <a:ln>
-                <a:noFill/>
-              </a:ln>
-              <a:solidFill>
-                <a:schemeClr val="tx1"/>
-              </a:solidFill>
-              <a:effectLst/>
-              <a:latin typeface="Arial" panose="020B0604020202020204" pitchFamily="34" charset="0"/>
-            </a:endParaRPr>
-          </a:p>
-          <a:p>
-            <a:pPr marL="0" marR="0" lvl="0" indent="0" algn="l" defTabSz="914400" rtl="0" eaLnBrk="0" fontAlgn="base" latinLnBrk="0" hangingPunct="0">
-              <a:lnSpc>
-                <a:spcPct val="100000"/>
-              </a:lnSpc>
-              <a:spcBef>
-                <a:spcPct val="0"/>
-              </a:spcBef>
-              <a:spcAft>
-                <a:spcPct val="0"/>
-              </a:spcAft>
-              <a:buClrTx/>
-              <a:buSzTx/>
-              <a:buFontTx/>
-              <a:buNone/>
-              <a:tabLst/>
-            </a:pPr>
-            <a:endParaRPr lang="en-US" altLang="en-US" sz="1800">
-              <a:solidFill>
-                <a:schemeClr val="tx1"/>
-              </a:solidFill>
-              <a:latin typeface="Arial" panose="020B0604020202020204" pitchFamily="34" charset="0"/>
-            </a:endParaRPr>
-          </a:p>
-          <a:p>
-            <a:pPr marL="0" marR="0" lvl="0" indent="0" algn="l" defTabSz="914400" rtl="0" eaLnBrk="0" fontAlgn="base" latinLnBrk="0" hangingPunct="0">
-              <a:lnSpc>
-                <a:spcPct val="100000"/>
-              </a:lnSpc>
-              <a:spcBef>
-                <a:spcPct val="0"/>
-              </a:spcBef>
-              <a:spcAft>
-                <a:spcPct val="0"/>
-              </a:spcAft>
-              <a:buClrTx/>
-              <a:buSzTx/>
-              <a:buFontTx/>
-              <a:buNone/>
-              <a:tabLst/>
-            </a:pPr>
-            <a:endParaRPr kumimoji="0" lang="en-US" altLang="en-US" sz="1800" b="0" i="0" u="none" strike="noStrike" cap="none" normalizeH="0" baseline="0">
-              <a:ln>
-                <a:noFill/>
-              </a:ln>
-              <a:solidFill>
-                <a:schemeClr val="tx1"/>
-              </a:solidFill>
-              <a:effectLst/>
-              <a:latin typeface="Arial" panose="020B0604020202020204" pitchFamily="34" charset="0"/>
-            </a:endParaRPr>
-          </a:p>
-          <a:p>
-            <a:pPr marL="0" marR="0" lvl="0" indent="0" algn="l" defTabSz="914400" rtl="0" eaLnBrk="0" fontAlgn="base" latinLnBrk="0" hangingPunct="0">
-              <a:lnSpc>
-                <a:spcPct val="100000"/>
-              </a:lnSpc>
-              <a:spcBef>
-                <a:spcPct val="0"/>
-              </a:spcBef>
-              <a:spcAft>
-                <a:spcPct val="0"/>
-              </a:spcAft>
-              <a:buClrTx/>
-              <a:buSzTx/>
-              <a:buFontTx/>
-              <a:buNone/>
-              <a:tabLst/>
-            </a:pPr>
-            <a:endParaRPr lang="en-US" altLang="en-US" sz="1800">
-              <a:solidFill>
-                <a:schemeClr val="tx1"/>
-              </a:solidFill>
-              <a:latin typeface="Arial" panose="020B0604020202020204" pitchFamily="34" charset="0"/>
-            </a:endParaRPr>
-          </a:p>
-          <a:p>
-            <a:pPr marL="0" marR="0" lvl="0" indent="0" algn="l" defTabSz="914400" rtl="0" eaLnBrk="0" fontAlgn="base" latinLnBrk="0" hangingPunct="0">
-              <a:lnSpc>
-                <a:spcPct val="100000"/>
-              </a:lnSpc>
-              <a:spcBef>
-                <a:spcPct val="0"/>
-              </a:spcBef>
-              <a:spcAft>
-                <a:spcPct val="0"/>
-              </a:spcAft>
-              <a:buClrTx/>
-              <a:buSzTx/>
-              <a:buFontTx/>
-              <a:buNone/>
-              <a:tabLst/>
-            </a:pPr>
-            <a:endParaRPr kumimoji="0" lang="en-US" altLang="en-US" sz="1800" b="0" i="0" u="none" strike="noStrike" cap="none" normalizeH="0" baseline="0">
-              <a:ln>
-                <a:noFill/>
-              </a:ln>
-              <a:solidFill>
-                <a:schemeClr val="tx1"/>
-              </a:solidFill>
-              <a:effectLst/>
-              <a:latin typeface="Arial" panose="020B0604020202020204" pitchFamily="34" charset="0"/>
-            </a:endParaRPr>
-          </a:p>
-          <a:p>
-            <a:pPr marL="0" marR="0" lvl="0" indent="0" algn="l" defTabSz="914400" rtl="0" eaLnBrk="0" fontAlgn="base" latinLnBrk="0" hangingPunct="0">
-              <a:lnSpc>
-                <a:spcPct val="100000"/>
-              </a:lnSpc>
-              <a:spcBef>
-                <a:spcPct val="0"/>
-              </a:spcBef>
-              <a:spcAft>
-                <a:spcPct val="0"/>
-              </a:spcAft>
-              <a:buClrTx/>
-              <a:buSzTx/>
-              <a:buFontTx/>
-              <a:buNone/>
-              <a:tabLst/>
-            </a:pPr>
-            <a:endParaRPr lang="en-US" altLang="en-US" sz="1800">
-              <a:solidFill>
-                <a:schemeClr val="tx1"/>
-              </a:solidFill>
-              <a:latin typeface="Arial" panose="020B0604020202020204" pitchFamily="34" charset="0"/>
-            </a:endParaRPr>
-          </a:p>
-        </p:txBody>
-      </p:sp>
-    </p:spTree>
-    <p:extLst>
-      <p:ext uri="{BB962C8B-B14F-4D97-AF65-F5344CB8AC3E}">
-        <p14:creationId xmlns:p14="http://schemas.microsoft.com/office/powerpoint/2010/main" val="1889464177"/>
-      </p:ext>
-    </p:extLst>
-  </p:cSld>
-  <p:clrMapOvr>
-    <a:masterClrMapping/>
-  </p:clrMapOvr>
-</p:sld>
-</file>
-
-<file path=ppt/slides/slide4.xml><?xml version="1.0" encoding="utf-8"?>
-<p:sld xmlns:a="http://schemas.openxmlformats.org/drawingml/2006/main" xmlns:r="http://schemas.openxmlformats.org/officeDocument/2006/relationships" xmlns:p="http://schemas.openxmlformats.org/presentationml/2006/main">
-  <p:cSld>
-    <p:spTree>
-      <p:nvGrpSpPr>
-        <p:cNvPr id="1" name="Shape 64"/>
-        <p:cNvGrpSpPr/>
-        <p:nvPr/>
-      </p:nvGrpSpPr>
-      <p:grpSpPr>
-        <a:xfrm>
-          <a:off x="0" y="0"/>
-          <a:ext cx="0" cy="0"/>
-          <a:chOff x="0" y="0"/>
-          <a:chExt cx="0" cy="0"/>
-        </a:xfrm>
-      </p:grpSpPr>
-      <p:sp>
-        <p:nvSpPr>
-          <p:cNvPr id="65" name="Google Shape;65;p3"/>
+          <p:cNvPr id="2" name="Title"/>
           <p:cNvSpPr txBox="1">
             <a:spLocks noGrp="1"/>
           </p:cNvSpPr>
@@ -7397,8 +8215,8 @@
         </p:nvSpPr>
         <p:spPr>
           <a:xfrm>
-            <a:off x="69573" y="-10601"/>
-            <a:ext cx="5361155" cy="682662"/>
+            <a:off x="-387625" y="109377"/>
+            <a:ext cx="5889474" cy="537306"/>
           </a:xfrm>
           <a:prstGeom prst="rect">
             <a:avLst/>
@@ -7409,12 +8227,12 @@
           </a:ln>
         </p:spPr>
         <p:txBody>
-          <a:bodyPr spcFirstLastPara="1" wrap="square" lIns="0" tIns="157900" rIns="0" bIns="0" anchor="t" anchorCtr="0">
+          <a:bodyPr spcFirstLastPara="1" wrap="square" lIns="0" tIns="13950" rIns="0" bIns="0" anchor="t" anchorCtr="0">
             <a:spAutoFit/>
           </a:bodyPr>
           <a:lstStyle/>
           <a:p>
-            <a:pPr marL="12700" lvl="0" indent="0" algn="l" rtl="0">
+            <a:pPr marL="601980" lvl="0" indent="0" algn="l" rtl="0">
               <a:lnSpc>
                 <a:spcPct val="100000"/>
               </a:lnSpc>
@@ -7430,13 +8248,12 @@
               <a:rPr lang="en-US"/>
               <a:t>Problem Statement</a:t>
             </a:r>
-            <a:endParaRPr/>
           </a:p>
         </p:txBody>
       </p:sp>
       <p:sp>
         <p:nvSpPr>
-          <p:cNvPr id="66" name="Google Shape;66;p3"/>
+          <p:cNvPr id="3" name="Footer"/>
           <p:cNvSpPr txBox="1">
             <a:spLocks noGrp="1"/>
           </p:cNvSpPr>
@@ -7477,9 +8294,149 @@
             </a:pPr>
             <a:r>
               <a:rPr lang="en-US"/>
-              <a:t>2</a:t>
-            </a:r>
-            <a:endParaRPr/>
+              <a:t>3</a:t>
+            </a:r>
+          </a:p>
+        </p:txBody>
+      </p:sp>
+      <p:sp>
+        <p:nvSpPr>
+          <p:cNvPr id="100" name="ContentBox"/>
+          <p:cNvSpPr txBox="1"/>
+          <p:nvPr/>
+        </p:nvSpPr>
+        <p:spPr>
+          <a:xfrm>
+            <a:off x="276876" y="1032103"/>
+            <a:ext cx="8800000" cy="6100000"/>
+          </a:xfrm>
+          <a:prstGeom prst="rect">
+            <a:avLst/>
+          </a:prstGeom>
+          <a:noFill/>
+          <a:ln>
+            <a:noFill/>
+          </a:ln>
+        </p:spPr>
+        <p:txBody>
+          <a:bodyPr wrap="square" lIns="91440" tIns="45720" rIns="91440" bIns="45720" anchor="t">
+            <a:spAutoFit/>
+          </a:bodyPr>
+          <a:lstStyle/>
+          <a:p>
+            <a:pPr algn="l">
+              <a:spcBef>
+                <a:spcPts val="0"/>
+              </a:spcBef>
+            </a:pPr>
+            <a:r>
+              <a:rPr lang="en-US" sz="1800" b="1" dirty="0">
+                <a:solidFill>
+                  <a:srgbClr val="CC0000"/>
+                </a:solidFill>
+              </a:rPr>
+              <a:t>Core Problem</a:t>
+            </a:r>
+          </a:p>
+          <a:p>
+            <a:pPr algn="l">
+              <a:spcBef>
+                <a:spcPts val="200"/>
+              </a:spcBef>
+            </a:pPr>
+            <a:r>
+              <a:rPr lang="en-US" sz="1500" dirty="0"/>
+              <a:t>Standard RAG pipelines split source code by fixed character count (chunk_size=1000), ignoring Python syntax. The offset k in cᵢ = S[k : k + chunk_size] is determined purely by character count — not by semantic or syntactic boundaries.</a:t>
+            </a:r>
+          </a:p>
+          <a:p>
+            <a:pPr algn="l">
+              <a:spcBef>
+                <a:spcPts val="400"/>
+              </a:spcBef>
+            </a:pPr>
+            <a:r>
+              <a:rPr lang="en-US" sz="1800" b="1" dirty="0">
+                <a:solidFill>
+                  <a:srgbClr val="CC0000"/>
+                </a:solidFill>
+              </a:rPr>
+              <a:t>Resulting Failure Modes</a:t>
+            </a:r>
+          </a:p>
+          <a:p>
+            <a:pPr marL="228600" indent="-228600" algn="l">
+              <a:spcBef>
+                <a:spcPts val="200"/>
+              </a:spcBef>
+              <a:buChar char="•"/>
+            </a:pPr>
+            <a:r>
+              <a:rPr lang="en-US" sz="1500" b="1" dirty="0"/>
+              <a:t>Context Fragmentation: </a:t>
+            </a:r>
+            <a:r>
+              <a:rPr lang="en-US" sz="1500" dirty="0"/>
+              <a:t>Chunks start mid-function or mid-class, losing the function signature and docstring that LLMs need for understanding.</a:t>
+            </a:r>
+          </a:p>
+          <a:p>
+            <a:pPr marL="228600" indent="-228600" algn="l">
+              <a:spcBef>
+                <a:spcPts val="200"/>
+              </a:spcBef>
+              <a:buChar char="•"/>
+            </a:pPr>
+            <a:r>
+              <a:rPr lang="en-US" sz="1500" b="1" dirty="0"/>
+              <a:t>Keyword Blindness: </a:t>
+            </a:r>
+            <a:r>
+              <a:rPr lang="en-US" sz="1500" dirty="0"/>
+              <a:t>When two functions are merged in one chunk, shorter keyword-dense functions outrank the intended target, diluting embedding precision.</a:t>
+            </a:r>
+          </a:p>
+          <a:p>
+            <a:pPr marL="228600" indent="-228600" algn="l">
+              <a:spcBef>
+                <a:spcPts val="200"/>
+              </a:spcBef>
+              <a:buChar char="•"/>
+            </a:pPr>
+            <a:r>
+              <a:rPr lang="en-US" sz="1500" b="1" dirty="0"/>
+              <a:t>Wrong File Retrieval: </a:t>
+            </a:r>
+            <a:r>
+              <a:rPr lang="en-US" sz="1500" dirty="0"/>
+              <a:t>Test files containing related method names can rank above the source implementation, returning irrelevant scaffolding code.</a:t>
+            </a:r>
+          </a:p>
+          <a:p>
+            <a:pPr algn="l">
+              <a:spcBef>
+                <a:spcPts val="400"/>
+              </a:spcBef>
+            </a:pPr>
+            <a:r>
+              <a:rPr lang="en-US" sz="1800" b="1" dirty="0">
+                <a:solidFill>
+                  <a:srgbClr val="CC0000"/>
+                </a:solidFill>
+              </a:rPr>
+              <a:t>Research Question</a:t>
+            </a:r>
+          </a:p>
+          <a:p>
+            <a:pPr algn="l">
+              <a:spcBef>
+                <a:spcPts val="200"/>
+              </a:spcBef>
+            </a:pPr>
+            <a:r>
+              <a:rPr lang="en-US" sz="1500" dirty="0"/>
+              <a:t>Does substituting fixed-size chunking with AST-aware, Python-syntax-aligned semantic splitting improve code retrieval quality in a developer-focused RAG system?</a:t>
+            </a:r>
           </a:p>
         </p:txBody>
       </p:sp>
@@ -7491,12 +8448,12 @@
 </p:sld>
 </file>
 
-<file path=ppt/slides/slide5.xml><?xml version="1.0" encoding="utf-8"?>
+<file path=ppt/slides/slide4.xml><?xml version="1.0" encoding="utf-8"?>
 <p:sld xmlns:a="http://schemas.openxmlformats.org/drawingml/2006/main" xmlns:r="http://schemas.openxmlformats.org/officeDocument/2006/relationships" xmlns:p="http://schemas.openxmlformats.org/presentationml/2006/main">
   <p:cSld>
     <p:spTree>
       <p:nvGrpSpPr>
-        <p:cNvPr id="1" name="Shape 71"/>
+        <p:cNvPr id="1" name="Shape 1"/>
         <p:cNvGrpSpPr/>
         <p:nvPr/>
       </p:nvGrpSpPr>
@@ -7510,7 +8467,7 @@
       </p:grpSpPr>
       <p:sp>
         <p:nvSpPr>
-          <p:cNvPr id="72" name="Google Shape;72;p4"/>
+          <p:cNvPr id="2" name="Title"/>
           <p:cNvSpPr txBox="1">
             <a:spLocks noGrp="1"/>
           </p:cNvSpPr>
@@ -7520,8 +8477,8 @@
         </p:nvSpPr>
         <p:spPr>
           <a:xfrm>
-            <a:off x="-834887" y="109377"/>
-            <a:ext cx="6336735" cy="690030"/>
+            <a:off x="-387625" y="109377"/>
+            <a:ext cx="5889474" cy="537306"/>
           </a:xfrm>
           <a:prstGeom prst="rect">
             <a:avLst/>
@@ -7532,12 +8489,12 @@
           </a:ln>
         </p:spPr>
         <p:txBody>
-          <a:bodyPr spcFirstLastPara="1" wrap="square" lIns="0" tIns="157900" rIns="0" bIns="0" anchor="t" anchorCtr="0">
+          <a:bodyPr spcFirstLastPara="1" wrap="square" lIns="0" tIns="13950" rIns="0" bIns="0" anchor="t" anchorCtr="0">
             <a:spAutoFit/>
           </a:bodyPr>
           <a:lstStyle/>
           <a:p>
-            <a:pPr marL="996314" lvl="0" indent="0" algn="l" rtl="0">
+            <a:pPr marL="601980" lvl="0" indent="0" algn="l" rtl="0">
               <a:lnSpc>
                 <a:spcPct val="100000"/>
               </a:lnSpc>
@@ -7550,62 +8507,15 @@
               <a:buNone/>
             </a:pPr>
             <a:r>
-              <a:rPr lang="en-US" dirty="0"/>
-              <a:t>Methodology</a:t>
-            </a:r>
-            <a:endParaRPr dirty="0"/>
+              <a:rPr lang="en-US"/>
+              <a:t>Objective</a:t>
+            </a:r>
           </a:p>
         </p:txBody>
       </p:sp>
       <p:sp>
         <p:nvSpPr>
-          <p:cNvPr id="73" name="Google Shape;73;p4"/>
-          <p:cNvSpPr txBox="1"/>
-          <p:nvPr/>
-        </p:nvSpPr>
-        <p:spPr>
-          <a:xfrm>
-            <a:off x="232155" y="1353176"/>
-            <a:ext cx="8766900" cy="502761"/>
-          </a:xfrm>
-          <a:prstGeom prst="rect">
-            <a:avLst/>
-          </a:prstGeom>
-          <a:noFill/>
-          <a:ln>
-            <a:noFill/>
-          </a:ln>
-        </p:spPr>
-        <p:txBody>
-          <a:bodyPr spcFirstLastPara="1" wrap="square" lIns="0" tIns="11425" rIns="0" bIns="0" anchor="t" anchorCtr="0">
-            <a:spAutoFit/>
-          </a:bodyPr>
-          <a:lstStyle/>
-          <a:p>
-            <a:pPr marL="95250" marR="8890" lvl="0" algn="just" rtl="0">
-              <a:lnSpc>
-                <a:spcPct val="151800"/>
-              </a:lnSpc>
-              <a:spcBef>
-                <a:spcPts val="0"/>
-              </a:spcBef>
-              <a:spcAft>
-                <a:spcPts val="0"/>
-              </a:spcAft>
-              <a:buSzPts val="2100"/>
-            </a:pPr>
-            <a:endParaRPr lang="en-US" sz="2100">
-              <a:latin typeface="Times New Roman"/>
-              <a:ea typeface="Times New Roman"/>
-              <a:cs typeface="Times New Roman"/>
-              <a:sym typeface="Times New Roman"/>
-            </a:endParaRPr>
-          </a:p>
-        </p:txBody>
-      </p:sp>
-      <p:sp>
-        <p:nvSpPr>
-          <p:cNvPr id="74" name="Google Shape;74;p4"/>
+          <p:cNvPr id="3" name="Footer"/>
           <p:cNvSpPr txBox="1">
             <a:spLocks noGrp="1"/>
           </p:cNvSpPr>
@@ -7646,60 +8556,464 @@
             </a:pPr>
             <a:r>
               <a:rPr lang="en-US"/>
-              <a:t>2</a:t>
-            </a:r>
-            <a:endParaRPr/>
+              <a:t>4</a:t>
+            </a:r>
           </a:p>
         </p:txBody>
       </p:sp>
       <p:sp>
         <p:nvSpPr>
-          <p:cNvPr id="11" name="TextBox 10">
-            <a:extLst>
-              <a:ext uri="{FF2B5EF4-FFF2-40B4-BE49-F238E27FC236}">
-                <a16:creationId xmlns:a16="http://schemas.microsoft.com/office/drawing/2014/main" id="{1D24BEFD-D9F7-342D-79FF-EFF9F785CCA7}"/>
-              </a:ext>
-            </a:extLst>
-          </p:cNvPr>
+          <p:cNvPr id="100" name="ContentBox"/>
           <p:cNvSpPr txBox="1"/>
           <p:nvPr/>
         </p:nvSpPr>
         <p:spPr>
           <a:xfrm>
-            <a:off x="754545" y="1604556"/>
-            <a:ext cx="8029532" cy="461665"/>
+            <a:off x="332121" y="993191"/>
+            <a:ext cx="8800000" cy="6100000"/>
           </a:xfrm>
           <a:prstGeom prst="rect">
             <a:avLst/>
           </a:prstGeom>
           <a:noFill/>
+          <a:ln>
+            <a:noFill/>
+          </a:ln>
         </p:spPr>
         <p:txBody>
-          <a:bodyPr wrap="square">
+          <a:bodyPr wrap="square" lIns="91440" tIns="45720" rIns="91440" bIns="45720" anchor="t">
             <a:spAutoFit/>
           </a:bodyPr>
           <a:lstStyle/>
           <a:p>
-            <a:pPr marL="0" marR="0" lvl="0" indent="0" algn="l" defTabSz="914400" rtl="0" eaLnBrk="0" fontAlgn="base" latinLnBrk="0" hangingPunct="0">
+            <a:pPr algn="l">
+              <a:spcBef>
+                <a:spcPts val="0"/>
+              </a:spcBef>
+            </a:pPr>
+            <a:r>
+              <a:rPr lang="en-US" sz="1600" dirty="0"/>
+              <a:t>This study aims to:</a:t>
+            </a:r>
+          </a:p>
+          <a:p>
+            <a:pPr marL="228600" indent="-228600" algn="l">
+              <a:spcBef>
+                <a:spcPts val="300"/>
+              </a:spcBef>
+              <a:buChar char="•"/>
+            </a:pPr>
+            <a:r>
+              <a:rPr lang="en-US" sz="1600" dirty="0"/>
+              <a:t>Perform a </a:t>
+            </a:r>
+            <a:r>
+              <a:rPr lang="en-US" sz="1600" b="1" dirty="0"/>
+              <a:t>controlled comparison</a:t>
+            </a:r>
+            <a:r>
+              <a:rPr lang="en-US" sz="1600" dirty="0"/>
+              <a:t> of fixed-size vs. AST-aware chunking strategies over a real-world Python codebase (Flask web framework, 83 source files).</a:t>
+            </a:r>
+          </a:p>
+          <a:p>
+            <a:pPr marL="228600" indent="-228600" algn="l">
+              <a:spcBef>
+                <a:spcPts val="300"/>
+              </a:spcBef>
+              <a:buChar char="•"/>
+            </a:pPr>
+            <a:r>
+              <a:rPr lang="en-US" sz="1600" dirty="0"/>
+              <a:t>Identify and </a:t>
+            </a:r>
+            <a:r>
+              <a:rPr lang="en-US" sz="1600" b="1" dirty="0"/>
+              <a:t>characterize failure modes</a:t>
+            </a:r>
+            <a:r>
+              <a:rPr lang="en-US" sz="1600" dirty="0"/>
+              <a:t> (context fragmentation, keyword blindness) in baseline character-based RAG retrieval.</a:t>
+            </a:r>
+          </a:p>
+          <a:p>
+            <a:pPr marL="228600" indent="-228600" algn="l">
+              <a:spcBef>
+                <a:spcPts val="300"/>
+              </a:spcBef>
+              <a:buChar char="•"/>
+            </a:pPr>
+            <a:r>
+              <a:rPr lang="en-US" sz="1600" dirty="0"/>
+              <a:t>Provide </a:t>
+            </a:r>
+            <a:r>
+              <a:rPr lang="en-US" sz="1600" b="1" dirty="0"/>
+              <a:t>empirical evidence</a:t>
+            </a:r>
+            <a:r>
+              <a:rPr lang="en-US" sz="1600" dirty="0"/>
+              <a:t> that semantic chunking produces syntactically complete, self-contained code units that improve retrieval precision.</a:t>
+            </a:r>
+          </a:p>
+          <a:p>
+            <a:pPr marL="228600" indent="-228600" algn="l">
+              <a:spcBef>
+                <a:spcPts val="300"/>
+              </a:spcBef>
+              <a:buChar char="•"/>
+            </a:pPr>
+            <a:r>
+              <a:rPr lang="en-US" sz="1600" dirty="0"/>
+              <a:t>Demonstrate an </a:t>
+            </a:r>
+            <a:r>
+              <a:rPr lang="en-US" sz="1600" b="1" dirty="0"/>
+              <a:t>open-source, reproducible experimental framework</a:t>
+            </a:r>
+            <a:r>
+              <a:rPr lang="en-US" sz="1600" dirty="0"/>
+              <a:t> using LangChain, ChromaDB, and HuggingFace — no proprietary services required.</a:t>
+            </a:r>
+          </a:p>
+          <a:p>
+            <a:pPr marL="228600" indent="-228600" algn="l">
+              <a:spcBef>
+                <a:spcPts val="300"/>
+              </a:spcBef>
+              <a:buChar char="•"/>
+            </a:pPr>
+            <a:r>
+              <a:rPr lang="en-US" sz="1600" dirty="0"/>
+              <a:t>Evaluate retrieval across </a:t>
+            </a:r>
+            <a:r>
+              <a:rPr lang="en-US" sz="1600" b="1" dirty="0"/>
+              <a:t>20 developer-focused natural language queries</a:t>
+            </a:r>
+            <a:r>
+              <a:rPr lang="en-US" sz="1600" dirty="0"/>
+              <a:t> covering method behaviour, class structure, lifecycle, configuration, and CLI patterns.</a:t>
+            </a:r>
+          </a:p>
+          <a:p>
+            <a:pPr marL="228600" indent="-228600" algn="l">
+              <a:spcBef>
+                <a:spcPts val="300"/>
+              </a:spcBef>
+              <a:buChar char="•"/>
+            </a:pPr>
+            <a:r>
+              <a:rPr lang="en-US" sz="1600" dirty="0"/>
+              <a:t>Show that AST-aware chunking is a </a:t>
+            </a:r>
+            <a:r>
+              <a:rPr lang="en-US" sz="1600" b="1" dirty="0"/>
+              <a:t>zero-cost, drop-in upgrade</a:t>
+            </a:r>
+            <a:r>
+              <a:rPr lang="en-US" sz="1600" dirty="0"/>
+              <a:t> over any existing LangChain-based RAG pipeline for code.</a:t>
+            </a:r>
+          </a:p>
+        </p:txBody>
+      </p:sp>
+    </p:spTree>
+  </p:cSld>
+  <p:clrMapOvr>
+    <a:masterClrMapping/>
+  </p:clrMapOvr>
+</p:sld>
+</file>
+
+<file path=ppt/slides/slide5.xml><?xml version="1.0" encoding="utf-8"?>
+<p:sld xmlns:a="http://schemas.openxmlformats.org/drawingml/2006/main" xmlns:r="http://schemas.openxmlformats.org/officeDocument/2006/relationships" xmlns:p="http://schemas.openxmlformats.org/presentationml/2006/main">
+  <p:cSld>
+    <p:spTree>
+      <p:nvGrpSpPr>
+        <p:cNvPr id="1" name="Shape 1"/>
+        <p:cNvGrpSpPr/>
+        <p:nvPr/>
+      </p:nvGrpSpPr>
+      <p:grpSpPr>
+        <a:xfrm>
+          <a:off x="0" y="0"/>
+          <a:ext cx="0" cy="0"/>
+          <a:chOff x="0" y="0"/>
+          <a:chExt cx="0" cy="0"/>
+        </a:xfrm>
+      </p:grpSpPr>
+      <p:sp>
+        <p:nvSpPr>
+          <p:cNvPr id="2" name="Title"/>
+          <p:cNvSpPr txBox="1">
+            <a:spLocks noGrp="1"/>
+          </p:cNvSpPr>
+          <p:nvPr>
+            <p:ph type="title"/>
+          </p:nvPr>
+        </p:nvSpPr>
+        <p:spPr>
+          <a:xfrm>
+            <a:off x="-387625" y="109377"/>
+            <a:ext cx="5889474" cy="537306"/>
+          </a:xfrm>
+          <a:prstGeom prst="rect">
+            <a:avLst/>
+          </a:prstGeom>
+          <a:noFill/>
+          <a:ln>
+            <a:noFill/>
+          </a:ln>
+        </p:spPr>
+        <p:txBody>
+          <a:bodyPr spcFirstLastPara="1" wrap="square" lIns="0" tIns="13950" rIns="0" bIns="0" anchor="t" anchorCtr="0">
+            <a:spAutoFit/>
+          </a:bodyPr>
+          <a:lstStyle/>
+          <a:p>
+            <a:pPr marL="601980" lvl="0" indent="0" algn="l" rtl="0">
               <a:lnSpc>
                 <a:spcPct val="100000"/>
               </a:lnSpc>
               <a:spcBef>
-                <a:spcPct val="0"/>
-              </a:spcBef>
-              <a:spcAft>
-                <a:spcPct val="0"/>
-              </a:spcAft>
-              <a:buClrTx/>
-              <a:buSzTx/>
-              <a:buFontTx/>
+                <a:spcPts val="0"/>
+              </a:spcBef>
+              <a:spcAft>
+                <a:spcPts val="0"/>
+              </a:spcAft>
+              <a:buNone/>
+            </a:pPr>
+            <a:r>
+              <a:rPr lang="en-US"/>
+              <a:t>Literature Review</a:t>
+            </a:r>
+          </a:p>
+        </p:txBody>
+      </p:sp>
+      <p:sp>
+        <p:nvSpPr>
+          <p:cNvPr id="3" name="Footer"/>
+          <p:cNvSpPr txBox="1">
+            <a:spLocks noGrp="1"/>
+          </p:cNvSpPr>
+          <p:nvPr>
+            <p:ph type="ftr" idx="11"/>
+          </p:nvPr>
+        </p:nvSpPr>
+        <p:spPr>
+          <a:xfrm>
+            <a:off x="9076876" y="6801811"/>
+            <a:ext cx="110490" cy="220979"/>
+          </a:xfrm>
+          <a:prstGeom prst="rect">
+            <a:avLst/>
+          </a:prstGeom>
+          <a:noFill/>
+          <a:ln>
+            <a:noFill/>
+          </a:ln>
+        </p:spPr>
+        <p:txBody>
+          <a:bodyPr spcFirstLastPara="1" wrap="square" lIns="0" tIns="8250" rIns="0" bIns="0" anchor="t" anchorCtr="0">
+            <a:spAutoFit/>
+          </a:bodyPr>
+          <a:lstStyle/>
+          <a:p>
+            <a:pPr marL="12700" lvl="0" indent="0" algn="l" rtl="0">
+              <a:lnSpc>
+                <a:spcPct val="100000"/>
+              </a:lnSpc>
+              <a:spcBef>
+                <a:spcPts val="0"/>
+              </a:spcBef>
+              <a:spcAft>
+                <a:spcPts val="0"/>
+              </a:spcAft>
+              <a:buNone/>
+            </a:pPr>
+            <a:r>
+              <a:rPr lang="en-US"/>
+              <a:t>5</a:t>
+            </a:r>
+          </a:p>
+        </p:txBody>
+      </p:sp>
+      <p:sp>
+        <p:nvSpPr>
+          <p:cNvPr id="100" name="ContentBox"/>
+          <p:cNvSpPr txBox="1"/>
+          <p:nvPr/>
+        </p:nvSpPr>
+        <p:spPr>
+          <a:xfrm>
+            <a:off x="276876" y="1105823"/>
+            <a:ext cx="8800000" cy="6100000"/>
+          </a:xfrm>
+          <a:prstGeom prst="rect">
+            <a:avLst/>
+          </a:prstGeom>
+          <a:noFill/>
+          <a:ln>
+            <a:noFill/>
+          </a:ln>
+        </p:spPr>
+        <p:txBody>
+          <a:bodyPr wrap="square" lIns="91440" tIns="45720" rIns="91440" bIns="45720" anchor="t">
+            <a:spAutoFit/>
+          </a:bodyPr>
+          <a:lstStyle/>
+          <a:p>
+            <a:pPr algn="l">
+              <a:spcBef>
+                <a:spcPts val="0"/>
+              </a:spcBef>
+            </a:pPr>
+            <a:r>
+              <a:rPr lang="en-US" sz="1800" b="1" dirty="0">
+                <a:solidFill>
+                  <a:srgbClr val="CC0000"/>
+                </a:solidFill>
+              </a:rPr>
+              <a:t>RAG Foundations</a:t>
+            </a:r>
+          </a:p>
+          <a:p>
+            <a:pPr marL="228600" indent="-228600" algn="l">
+              <a:spcBef>
+                <a:spcPts val="150"/>
+              </a:spcBef>
               <a:buChar char="•"/>
-              <a:tabLst/>
-            </a:pPr>
-            <a:endParaRPr lang="en-IN" sz="2400">
-              <a:latin typeface="Times New Roman" panose="02020603050405020304" pitchFamily="18" charset="0"/>
-              <a:cs typeface="Times New Roman" panose="02020603050405020304" pitchFamily="18" charset="0"/>
-            </a:endParaRPr>
+            </a:pPr>
+            <a:r>
+              <a:rPr lang="en-US" sz="1400" b="1" dirty="0"/>
+              <a:t>Lewis et al. [2020]: </a:t>
+            </a:r>
+            <a:r>
+              <a:rPr lang="en-US" sz="1400" dirty="0"/>
+              <a:t>Introduced RAG framework fusing dense passage retrieval with seq2seq generation; no code support.</a:t>
+            </a:r>
+          </a:p>
+          <a:p>
+            <a:pPr marL="228600" indent="-228600" algn="l">
+              <a:spcBef>
+                <a:spcPts val="150"/>
+              </a:spcBef>
+              <a:buChar char="•"/>
+            </a:pPr>
+            <a:r>
+              <a:rPr lang="en-US" sz="1400" b="1" dirty="0"/>
+              <a:t>Asai et al. [Self-RAG, 2024]: </a:t>
+            </a:r>
+            <a:r>
+              <a:rPr lang="en-US" sz="1400" dirty="0"/>
+              <a:t>LLM decides when to retrieve and whether passages are useful; reduces irrelevant context in output.</a:t>
+            </a:r>
+          </a:p>
+          <a:p>
+            <a:pPr algn="l">
+              <a:spcBef>
+                <a:spcPts val="300"/>
+              </a:spcBef>
+            </a:pPr>
+            <a:r>
+              <a:rPr lang="en-US" sz="1800" b="1" dirty="0">
+                <a:solidFill>
+                  <a:srgbClr val="CC0000"/>
+                </a:solidFill>
+              </a:rPr>
+              <a:t>Code-Specific RAG &amp; Chunking</a:t>
+            </a:r>
+          </a:p>
+          <a:p>
+            <a:pPr marL="228600" indent="-228600" algn="l">
+              <a:spcBef>
+                <a:spcPts val="150"/>
+              </a:spcBef>
+              <a:buChar char="•"/>
+            </a:pPr>
+            <a:r>
+              <a:rPr lang="en-US" sz="1400" b="1" dirty="0"/>
+              <a:t>Wang et al. [CodeRAG-Bench, 2025]: </a:t>
+            </a:r>
+            <a:r>
+              <a:rPr lang="en-US" sz="1400" dirty="0"/>
+              <a:t>Found chunk sizes 200–800 tokens optimal; no AST awareness evaluated.</a:t>
+            </a:r>
+          </a:p>
+          <a:p>
+            <a:pPr marL="228600" indent="-228600" algn="l">
+              <a:spcBef>
+                <a:spcPts val="150"/>
+              </a:spcBef>
+              <a:buChar char="•"/>
+            </a:pPr>
+            <a:r>
+              <a:rPr lang="en-US" sz="1400" b="1" dirty="0"/>
+              <a:t>Ding et al. [CrossCodeEval, 2023]: </a:t>
+            </a:r>
+            <a:r>
+              <a:rPr lang="en-US" sz="1400" dirty="0"/>
+              <a:t>Function-level granularity outperforms file-level and line-level for cross-file code completion; no comparison study.</a:t>
+            </a:r>
+          </a:p>
+          <a:p>
+            <a:pPr marL="228600" indent="-228600" algn="l">
+              <a:spcBef>
+                <a:spcPts val="150"/>
+              </a:spcBef>
+              <a:buChar char="•"/>
+            </a:pPr>
+            <a:r>
+              <a:rPr lang="en-US" sz="1400" b="1" dirty="0"/>
+              <a:t>Zhang et al. [RepoCoder, 2023]: </a:t>
+            </a:r>
+            <a:r>
+              <a:rPr lang="en-US" sz="1400" dirty="0"/>
+              <a:t>Iterative function-level retrieval for repository code using BM25; no controlled comparison.</a:t>
+            </a:r>
+          </a:p>
+          <a:p>
+            <a:pPr marL="228600" indent="-228600" algn="l">
+              <a:spcBef>
+                <a:spcPts val="150"/>
+              </a:spcBef>
+              <a:buChar char="•"/>
+            </a:pPr>
+            <a:r>
+              <a:rPr lang="en-US" sz="1400" b="1" dirty="0"/>
+              <a:t>Zhou et al. [DocPrompting, 2023]: </a:t>
+            </a:r>
+            <a:r>
+              <a:rPr lang="en-US" sz="1400" dirty="0"/>
+              <a:t>Document-level retrieval for library docs; no function isolation in chunks.</a:t>
+            </a:r>
+          </a:p>
+          <a:p>
+            <a:pPr algn="l">
+              <a:spcBef>
+                <a:spcPts val="300"/>
+              </a:spcBef>
+            </a:pPr>
+            <a:r>
+              <a:rPr lang="en-US" sz="1800" b="1" dirty="0">
+                <a:solidFill>
+                  <a:srgbClr val="CC0000"/>
+                </a:solidFill>
+              </a:rPr>
+              <a:t>Research Gap Addressed</a:t>
+            </a:r>
+          </a:p>
+          <a:p>
+            <a:pPr algn="l">
+              <a:spcBef>
+                <a:spcPts val="150"/>
+              </a:spcBef>
+            </a:pPr>
+            <a:r>
+              <a:rPr lang="en-US" sz="1400" dirty="0"/>
+              <a:t>No prior study simultaneously applies AST-aware semantic chunking to a Python library corpus stored in ChromaDB with a controlled side-by-side comparison — this paper fills that gap.</a:t>
+            </a:r>
           </a:p>
         </p:txBody>
       </p:sp>
@@ -7716,7 +9030,7 @@
   <p:cSld>
     <p:spTree>
       <p:nvGrpSpPr>
-        <p:cNvPr id="1" name="Shape 78"/>
+        <p:cNvPr id="1" name="Shape 1"/>
         <p:cNvGrpSpPr/>
         <p:nvPr/>
       </p:nvGrpSpPr>
@@ -7730,7 +9044,7 @@
       </p:grpSpPr>
       <p:sp>
         <p:nvSpPr>
-          <p:cNvPr id="79" name="Google Shape;79;g319ac019662_0_1"/>
+          <p:cNvPr id="2" name="Title"/>
           <p:cNvSpPr txBox="1">
             <a:spLocks noGrp="1"/>
           </p:cNvSpPr>
@@ -7740,20 +9054,27 @@
         </p:nvSpPr>
         <p:spPr>
           <a:xfrm>
-            <a:off x="99392" y="181802"/>
-            <a:ext cx="6156996" cy="523200"/>
+            <a:off x="-387625" y="109377"/>
+            <a:ext cx="5889474" cy="537306"/>
           </a:xfrm>
           <a:prstGeom prst="rect">
             <a:avLst/>
           </a:prstGeom>
+          <a:noFill/>
+          <a:ln>
+            <a:noFill/>
+          </a:ln>
         </p:spPr>
         <p:txBody>
-          <a:bodyPr spcFirstLastPara="1" wrap="square" lIns="0" tIns="0" rIns="0" bIns="0" anchor="t" anchorCtr="0">
+          <a:bodyPr spcFirstLastPara="1" wrap="square" lIns="0" tIns="13950" rIns="0" bIns="0" anchor="t" anchorCtr="0">
             <a:spAutoFit/>
           </a:bodyPr>
           <a:lstStyle/>
           <a:p>
-            <a:pPr marL="0" lvl="0" indent="0" algn="l" rtl="0">
+            <a:pPr marL="601980" lvl="0" indent="0" algn="l" rtl="0">
+              <a:lnSpc>
+                <a:spcPct val="100000"/>
+              </a:lnSpc>
               <a:spcBef>
                 <a:spcPts val="0"/>
               </a:spcBef>
@@ -7764,52 +9085,409 @@
             </a:pPr>
             <a:r>
               <a:rPr lang="en-US" dirty="0"/>
-              <a:t>Results &amp; Discussion</a:t>
-            </a:r>
-            <a:endParaRPr dirty="0"/>
+              <a:t>Methodology</a:t>
+            </a:r>
           </a:p>
         </p:txBody>
       </p:sp>
       <p:sp>
         <p:nvSpPr>
-          <p:cNvPr id="80" name="Google Shape;80;g319ac019662_0_1"/>
+          <p:cNvPr id="3" name="Footer"/>
           <p:cNvSpPr txBox="1">
             <a:spLocks noGrp="1"/>
           </p:cNvSpPr>
           <p:nvPr>
-            <p:ph type="body" idx="1"/>
+            <p:ph type="ftr" idx="11"/>
           </p:nvPr>
         </p:nvSpPr>
         <p:spPr>
-          <a:xfrm flipH="1">
-            <a:off x="9605818" y="7269481"/>
-            <a:ext cx="1098332" cy="45719"/>
+          <a:xfrm>
+            <a:off x="9076876" y="6801811"/>
+            <a:ext cx="110490" cy="220979"/>
           </a:xfrm>
           <a:prstGeom prst="rect">
             <a:avLst/>
           </a:prstGeom>
+          <a:noFill/>
+          <a:ln>
+            <a:noFill/>
+          </a:ln>
         </p:spPr>
         <p:txBody>
-          <a:bodyPr spcFirstLastPara="1" wrap="square" lIns="0" tIns="0" rIns="0" bIns="0" anchor="t" anchorCtr="0">
+          <a:bodyPr spcFirstLastPara="1" wrap="square" lIns="0" tIns="8250" rIns="0" bIns="0" anchor="t" anchorCtr="0">
             <a:spAutoFit/>
           </a:bodyPr>
           <a:lstStyle/>
           <a:p>
-            <a:pPr marL="0" lvl="0" indent="0" algn="l" rtl="0">
-              <a:spcBef>
-                <a:spcPts val="1200"/>
-              </a:spcBef>
-              <a:spcAft>
-                <a:spcPts val="0"/>
-              </a:spcAft>
-              <a:buNone/>
-            </a:pPr>
-            <a:endParaRPr sz="1100" b="1">
-              <a:latin typeface="Arial"/>
-              <a:ea typeface="Arial"/>
-              <a:cs typeface="Arial"/>
-              <a:sym typeface="Arial"/>
-            </a:endParaRPr>
+            <a:pPr marL="12700" lvl="0" indent="0" algn="l" rtl="0">
+              <a:lnSpc>
+                <a:spcPct val="100000"/>
+              </a:lnSpc>
+              <a:spcBef>
+                <a:spcPts val="0"/>
+              </a:spcBef>
+              <a:spcAft>
+                <a:spcPts val="0"/>
+              </a:spcAft>
+              <a:buNone/>
+            </a:pPr>
+            <a:r>
+              <a:rPr lang="en-US"/>
+              <a:t>6</a:t>
+            </a:r>
+          </a:p>
+        </p:txBody>
+      </p:sp>
+      <p:sp>
+        <p:nvSpPr>
+          <p:cNvPr id="100" name="LeftCol"/>
+          <p:cNvSpPr txBox="1"/>
+          <p:nvPr/>
+        </p:nvSpPr>
+        <p:spPr>
+          <a:xfrm>
+            <a:off x="165370" y="1022790"/>
+            <a:ext cx="4250000" cy="6000000"/>
+          </a:xfrm>
+          <a:prstGeom prst="rect">
+            <a:avLst/>
+          </a:prstGeom>
+          <a:noFill/>
+          <a:ln>
+            <a:noFill/>
+          </a:ln>
+        </p:spPr>
+        <p:txBody>
+          <a:bodyPr wrap="square" lIns="91440" tIns="45720" rIns="91440" bIns="45720" anchor="t">
+            <a:spAutoFit/>
+          </a:bodyPr>
+          <a:lstStyle/>
+          <a:p>
+            <a:pPr algn="l">
+              <a:spcBef>
+                <a:spcPts val="0"/>
+              </a:spcBef>
+            </a:pPr>
+            <a:r>
+              <a:rPr lang="en-US" sz="1800" b="1" dirty="0">
+                <a:solidFill>
+                  <a:srgbClr val="CC0000"/>
+                </a:solidFill>
+              </a:rPr>
+              <a:t>System Architecture (4 Stages)</a:t>
+            </a:r>
+          </a:p>
+          <a:p>
+            <a:pPr algn="l">
+              <a:spcBef>
+                <a:spcPts val="300"/>
+              </a:spcBef>
+            </a:pPr>
+            <a:r>
+              <a:rPr lang="en-US" sz="1500" b="1" dirty="0"/>
+              <a:t>Stage 1: Document Loader</a:t>
+            </a:r>
+          </a:p>
+          <a:p>
+            <a:pPr algn="l">
+              <a:spcBef>
+                <a:spcPts val="100"/>
+              </a:spcBef>
+            </a:pPr>
+            <a:r>
+              <a:rPr lang="en-US" sz="1400" dirty="0"/>
+              <a:t>LangChain DirectoryLoader + TextLoader ingests all 83 Flask .py source files, producing one Document object per file.</a:t>
+            </a:r>
+          </a:p>
+          <a:p>
+            <a:pPr algn="l">
+              <a:spcBef>
+                <a:spcPts val="300"/>
+              </a:spcBef>
+            </a:pPr>
+            <a:r>
+              <a:rPr lang="en-US" sz="1500" b="1" dirty="0"/>
+              <a:t>Stage 2: Chunking Module (differs per pipeline)</a:t>
+            </a:r>
+          </a:p>
+          <a:p>
+            <a:pPr algn="l">
+              <a:spcBef>
+                <a:spcPts val="100"/>
+              </a:spcBef>
+            </a:pPr>
+            <a:r>
+              <a:rPr lang="en-US" sz="1400" dirty="0"/>
+              <a:t>The single variable component — held constant everywhere else to isolate chunking effects.</a:t>
+            </a:r>
+          </a:p>
+          <a:p>
+            <a:pPr algn="l">
+              <a:spcBef>
+                <a:spcPts val="300"/>
+              </a:spcBef>
+            </a:pPr>
+            <a:r>
+              <a:rPr lang="en-US" sz="1500" b="1" dirty="0"/>
+              <a:t>Stage 3: Embedding Module</a:t>
+            </a:r>
+          </a:p>
+          <a:p>
+            <a:pPr algn="l">
+              <a:spcBef>
+                <a:spcPts val="100"/>
+              </a:spcBef>
+            </a:pPr>
+            <a:r>
+              <a:rPr lang="en-US" sz="1400" dirty="0"/>
+              <a:t>all-MiniLM-L6-v2 (22.7M parameters, 384-dim dense vectors). Identical for both pipelines.</a:t>
+            </a:r>
+          </a:p>
+          <a:p>
+            <a:pPr algn="l">
+              <a:spcBef>
+                <a:spcPts val="300"/>
+              </a:spcBef>
+            </a:pPr>
+            <a:r>
+              <a:rPr lang="en-US" sz="1500" b="1" dirty="0"/>
+              <a:t>Stage 4: ChromaDB Vector Store</a:t>
+            </a:r>
+          </a:p>
+          <a:p>
+            <a:pPr algn="l">
+              <a:spcBef>
+                <a:spcPts val="100"/>
+              </a:spcBef>
+            </a:pPr>
+            <a:r>
+              <a:rPr lang="en-US" sz="1400" dirty="0"/>
+              <a:t>Two separate persistent collections. Retrieval via cosine similarity, k=1 (strict single-best-match comparison).</a:t>
+            </a:r>
+          </a:p>
+          <a:p>
+            <a:pPr algn="l">
+              <a:spcBef>
+                <a:spcPts val="400"/>
+              </a:spcBef>
+            </a:pPr>
+            <a:r>
+              <a:rPr lang="en-US" sz="1500" b="1" dirty="0">
+                <a:solidFill>
+                  <a:srgbClr val="CC0000"/>
+                </a:solidFill>
+              </a:rPr>
+              <a:t>Dataset</a:t>
+            </a:r>
+          </a:p>
+          <a:p>
+            <a:pPr algn="l">
+              <a:spcBef>
+                <a:spcPts val="100"/>
+              </a:spcBef>
+            </a:pPr>
+            <a:r>
+              <a:rPr lang="en-US" sz="1400" dirty="0"/>
+              <a:t>Flask web framework (v3.x) — 83 .py files including app.py, blueprints.py, cli.py, config.py, ctx.py, wrappers.py, and test files. Diverse constructs: class hierarchies, decorators, context managers, type annotations.</a:t>
+            </a:r>
+          </a:p>
+        </p:txBody>
+      </p:sp>
+      <p:sp>
+        <p:nvSpPr>
+          <p:cNvPr id="101" name="RightCol"/>
+          <p:cNvSpPr txBox="1"/>
+          <p:nvPr/>
+        </p:nvSpPr>
+        <p:spPr>
+          <a:xfrm>
+            <a:off x="4876876" y="1022790"/>
+            <a:ext cx="4200000" cy="5880000"/>
+          </a:xfrm>
+          <a:prstGeom prst="rect">
+            <a:avLst/>
+          </a:prstGeom>
+          <a:solidFill>
+            <a:srgbClr val="F5F5F5"/>
+          </a:solidFill>
+          <a:ln w="12700">
+            <a:solidFill>
+              <a:srgbClr val="DDDDDD"/>
+            </a:solidFill>
+          </a:ln>
+        </p:spPr>
+        <p:txBody>
+          <a:bodyPr wrap="square" lIns="182880" tIns="182880" rIns="182880" bIns="182880" anchor="t">
+            <a:spAutoFit/>
+          </a:bodyPr>
+          <a:lstStyle/>
+          <a:p>
+            <a:pPr algn="ctr">
+              <a:spcBef>
+                <a:spcPts val="0"/>
+              </a:spcBef>
+            </a:pPr>
+            <a:r>
+              <a:rPr lang="en-US" sz="1600" b="1" dirty="0">
+                <a:solidFill>
+                  <a:srgbClr val="CC0000"/>
+                </a:solidFill>
+              </a:rPr>
+              <a:t>Hyperparameters</a:t>
+            </a:r>
+          </a:p>
+          <a:p>
+            <a:pPr algn="l">
+              <a:spcBef>
+                <a:spcPts val="300"/>
+              </a:spcBef>
+            </a:pPr>
+            <a:r>
+              <a:rPr lang="en-US" sz="1400" b="1" dirty="0"/>
+              <a:t>chunk_size: </a:t>
+            </a:r>
+            <a:r>
+              <a:rPr lang="en-US" sz="1400" dirty="0"/>
+              <a:t>1000 characters</a:t>
+            </a:r>
+          </a:p>
+          <a:p>
+            <a:pPr algn="l">
+              <a:spcBef>
+                <a:spcPts val="200"/>
+              </a:spcBef>
+            </a:pPr>
+            <a:r>
+              <a:rPr lang="en-US" sz="1400" b="1" dirty="0"/>
+              <a:t>chunk_overlap: </a:t>
+            </a:r>
+            <a:r>
+              <a:rPr lang="en-US" sz="1400" dirty="0"/>
+              <a:t>200 characters</a:t>
+            </a:r>
+          </a:p>
+          <a:p>
+            <a:pPr algn="l">
+              <a:spcBef>
+                <a:spcPts val="200"/>
+              </a:spcBef>
+            </a:pPr>
+            <a:r>
+              <a:rPr lang="en-US" sz="1400" b="1" dirty="0"/>
+              <a:t>Retrieval k: </a:t>
+            </a:r>
+            <a:r>
+              <a:rPr lang="en-US" sz="1400" dirty="0"/>
+              <a:t>1 (strict comparison)</a:t>
+            </a:r>
+          </a:p>
+          <a:p>
+            <a:pPr algn="l">
+              <a:spcBef>
+                <a:spcPts val="200"/>
+              </a:spcBef>
+            </a:pPr>
+            <a:r>
+              <a:rPr lang="en-US" sz="1400" b="1" dirty="0"/>
+              <a:t>Embedding dim: </a:t>
+            </a:r>
+            <a:r>
+              <a:rPr lang="en-US" sz="1400" dirty="0"/>
+              <a:t>384 (fixed by MiniLM)</a:t>
+            </a:r>
+          </a:p>
+          <a:p>
+            <a:pPr algn="l">
+              <a:spcBef>
+                <a:spcPts val="200"/>
+              </a:spcBef>
+            </a:pPr>
+            <a:r>
+              <a:rPr lang="en-US" sz="1400" b="1" dirty="0"/>
+              <a:t>Similarity: </a:t>
+            </a:r>
+            <a:r>
+              <a:rPr lang="en-US" sz="1400" dirty="0"/>
+              <a:t>Cosine (ChromaDB default)</a:t>
+            </a:r>
+          </a:p>
+          <a:p>
+            <a:pPr algn="l">
+              <a:spcBef>
+                <a:spcPts val="200"/>
+              </a:spcBef>
+            </a:pPr>
+            <a:r>
+              <a:rPr lang="en-US" sz="1400" b="1" dirty="0"/>
+              <a:t>Queries: </a:t>
+            </a:r>
+            <a:r>
+              <a:rPr lang="en-US" sz="1400" dirty="0"/>
+              <a:t>20 developer-focused NL questions</a:t>
+            </a:r>
+          </a:p>
+          <a:p>
+            <a:pPr algn="l">
+              <a:spcBef>
+                <a:spcPts val="400"/>
+              </a:spcBef>
+            </a:pPr>
+            <a:r>
+              <a:rPr lang="en-US" sz="1600" b="1" dirty="0">
+                <a:solidFill>
+                  <a:srgbClr val="CC0000"/>
+                </a:solidFill>
+              </a:rPr>
+              <a:t>Scoring Rubric</a:t>
+            </a:r>
+          </a:p>
+          <a:p>
+            <a:pPr marL="228600" indent="-228600" algn="l">
+              <a:spcBef>
+                <a:spcPts val="200"/>
+              </a:spcBef>
+              <a:buChar char="•"/>
+            </a:pPr>
+            <a:r>
+              <a:rPr lang="en-US" sz="1400" b="1" dirty="0"/>
+              <a:t>0 — Fail: </a:t>
+            </a:r>
+            <a:r>
+              <a:rPr lang="en-US" sz="1400" dirty="0"/>
+              <a:t>Wrong function or missing signature</a:t>
+            </a:r>
+          </a:p>
+          <a:p>
+            <a:pPr marL="228600" indent="-228600" algn="l">
+              <a:spcBef>
+                <a:spcPts val="200"/>
+              </a:spcBef>
+              <a:buChar char="•"/>
+            </a:pPr>
+            <a:r>
+              <a:rPr lang="en-US" sz="1400" b="1" dirty="0"/>
+              <a:t>1 — Partial: </a:t>
+            </a:r>
+            <a:r>
+              <a:rPr lang="en-US" sz="1400" dirty="0"/>
+              <a:t>Correct file, mid-body fragment</a:t>
+            </a:r>
+          </a:p>
+          <a:p>
+            <a:pPr marL="228600" indent="-228600" algn="l">
+              <a:spcBef>
+                <a:spcPts val="200"/>
+              </a:spcBef>
+              <a:buChar char="•"/>
+            </a:pPr>
+            <a:r>
+              <a:rPr lang="en-US" sz="1400" b="1" dirty="0"/>
+              <a:t>2 — Correct: </a:t>
+            </a:r>
+            <a:r>
+              <a:rPr lang="en-US" sz="1400" dirty="0"/>
+              <a:t>Full signature + docstring at chunk start</a:t>
+            </a:r>
           </a:p>
         </p:txBody>
       </p:sp>
@@ -7826,7 +9504,7 @@
   <p:cSld>
     <p:spTree>
       <p:nvGrpSpPr>
-        <p:cNvPr id="1" name=""/>
+        <p:cNvPr id="1" name="Shape 1"/>
         <p:cNvGrpSpPr/>
         <p:nvPr/>
       </p:nvGrpSpPr>
@@ -7840,70 +9518,7 @@
       </p:grpSpPr>
       <p:sp>
         <p:nvSpPr>
-          <p:cNvPr id="2" name="Title 1">
-            <a:extLst>
-              <a:ext uri="{FF2B5EF4-FFF2-40B4-BE49-F238E27FC236}">
-                <a16:creationId xmlns:a16="http://schemas.microsoft.com/office/drawing/2014/main" id="{91482F8F-47D9-0DC1-143F-DD694A2F8183}"/>
-              </a:ext>
-            </a:extLst>
-          </p:cNvPr>
-          <p:cNvSpPr>
-            <a:spLocks noGrp="1"/>
-          </p:cNvSpPr>
-          <p:nvPr>
-            <p:ph type="title"/>
-          </p:nvPr>
-        </p:nvSpPr>
-        <p:spPr>
-          <a:xfrm>
-            <a:off x="417443" y="109377"/>
-            <a:ext cx="5084405" cy="523220"/>
-          </a:xfrm>
-        </p:spPr>
-        <p:txBody>
-          <a:bodyPr/>
-          <a:lstStyle/>
-          <a:p>
-            <a:r>
-              <a:rPr lang="en-US" dirty="0"/>
-              <a:t>Conclusion</a:t>
-            </a:r>
-          </a:p>
-        </p:txBody>
-      </p:sp>
-    </p:spTree>
-    <p:extLst>
-      <p:ext uri="{BB962C8B-B14F-4D97-AF65-F5344CB8AC3E}">
-        <p14:creationId xmlns:p14="http://schemas.microsoft.com/office/powerpoint/2010/main" val="1403858061"/>
-      </p:ext>
-    </p:extLst>
-  </p:cSld>
-  <p:clrMapOvr>
-    <a:masterClrMapping/>
-  </p:clrMapOvr>
-</p:sld>
-</file>
-
-<file path=ppt/slides/slide8.xml><?xml version="1.0" encoding="utf-8"?>
-<p:sld xmlns:a="http://schemas.openxmlformats.org/drawingml/2006/main" xmlns:r="http://schemas.openxmlformats.org/officeDocument/2006/relationships" xmlns:p="http://schemas.openxmlformats.org/presentationml/2006/main">
-  <p:cSld>
-    <p:spTree>
-      <p:nvGrpSpPr>
-        <p:cNvPr id="1" name="Shape 104"/>
-        <p:cNvGrpSpPr/>
-        <p:nvPr/>
-      </p:nvGrpSpPr>
-      <p:grpSpPr>
-        <a:xfrm>
-          <a:off x="0" y="0"/>
-          <a:ext cx="0" cy="0"/>
-          <a:chOff x="0" y="0"/>
-          <a:chExt cx="0" cy="0"/>
-        </a:xfrm>
-      </p:grpSpPr>
-      <p:sp>
-        <p:nvSpPr>
-          <p:cNvPr id="105" name="Google Shape;105;p7"/>
+          <p:cNvPr id="2" name="Title"/>
           <p:cNvSpPr txBox="1">
             <a:spLocks noGrp="1"/>
           </p:cNvSpPr>
@@ -7913,8 +9528,8 @@
         </p:nvSpPr>
         <p:spPr>
           <a:xfrm>
-            <a:off x="3137882" y="2901732"/>
-            <a:ext cx="3644900" cy="3553517"/>
+            <a:off x="-282102" y="245565"/>
+            <a:ext cx="7490298" cy="506529"/>
           </a:xfrm>
           <a:prstGeom prst="rect">
             <a:avLst/>
@@ -7930,7 +9545,7 @@
           </a:bodyPr>
           <a:lstStyle/>
           <a:p>
-            <a:pPr marL="12700" lvl="0" indent="0" algn="l" rtl="0">
+            <a:pPr marL="601980" lvl="0" indent="0" algn="l" rtl="0">
               <a:lnSpc>
                 <a:spcPct val="100000"/>
               </a:lnSpc>
@@ -7943,32 +9558,26 @@
               <a:buNone/>
             </a:pPr>
             <a:r>
-              <a:rPr lang="en-US" sz="5750"/>
-              <a:t>Thank You</a:t>
-            </a:r>
-            <a:br>
-              <a:rPr lang="en-US" sz="5750"/>
-            </a:br>
-            <a:br>
-              <a:rPr lang="en-US" sz="5750"/>
-            </a:br>
-            <a:br>
-              <a:rPr lang="en-US" sz="5750"/>
-            </a:br>
-            <a:endParaRPr sz="5750"/>
+              <a:rPr lang="en-US" sz="3200" dirty="0"/>
+              <a:t>Methodology: Pipeline A vs Pipeline B</a:t>
+            </a:r>
           </a:p>
         </p:txBody>
       </p:sp>
       <p:sp>
         <p:nvSpPr>
-          <p:cNvPr id="106" name="Google Shape;106;p7"/>
-          <p:cNvSpPr txBox="1"/>
-          <p:nvPr/>
+          <p:cNvPr id="3" name="Footer"/>
+          <p:cNvSpPr txBox="1">
+            <a:spLocks noGrp="1"/>
+          </p:cNvSpPr>
+          <p:nvPr>
+            <p:ph type="ftr" idx="11"/>
+          </p:nvPr>
         </p:nvSpPr>
         <p:spPr>
           <a:xfrm>
-            <a:off x="9074494" y="6801811"/>
-            <a:ext cx="112395" cy="220979"/>
+            <a:off x="9076876" y="6801811"/>
+            <a:ext cx="110490" cy="220979"/>
           </a:xfrm>
           <a:prstGeom prst="rect">
             <a:avLst/>
@@ -7997,20 +9606,1168 @@
               <a:buNone/>
             </a:pPr>
             <a:r>
-              <a:rPr lang="en-US" sz="1250" b="1">
-                <a:latin typeface="Trebuchet MS"/>
-                <a:ea typeface="Trebuchet MS"/>
-                <a:cs typeface="Trebuchet MS"/>
-                <a:sym typeface="Trebuchet MS"/>
+              <a:rPr lang="en-US"/>
+              <a:t>7</a:t>
+            </a:r>
+          </a:p>
+        </p:txBody>
+      </p:sp>
+      <p:sp>
+        <p:nvSpPr>
+          <p:cNvPr id="100" name="PipelineA"/>
+          <p:cNvSpPr txBox="1"/>
+          <p:nvPr/>
+        </p:nvSpPr>
+        <p:spPr>
+          <a:xfrm>
+            <a:off x="457200" y="1001948"/>
+            <a:ext cx="3725694" cy="4283224"/>
+          </a:xfrm>
+          <a:prstGeom prst="rect">
+            <a:avLst/>
+          </a:prstGeom>
+          <a:solidFill>
+            <a:srgbClr val="FFF0F0"/>
+          </a:solidFill>
+          <a:ln w="19050">
+            <a:solidFill>
+              <a:srgbClr val="CC0000"/>
+            </a:solidFill>
+          </a:ln>
+        </p:spPr>
+        <p:txBody>
+          <a:bodyPr wrap="square" lIns="182880" tIns="182880" rIns="182880" bIns="182880" anchor="t">
+            <a:spAutoFit/>
+          </a:bodyPr>
+          <a:lstStyle/>
+          <a:p>
+            <a:pPr algn="ctr">
+              <a:spcBef>
+                <a:spcPts val="0"/>
+              </a:spcBef>
+            </a:pPr>
+            <a:r>
+              <a:rPr lang="en-US" sz="1800" b="1" dirty="0">
+                <a:solidFill>
+                  <a:srgbClr val="CC0000"/>
+                </a:solidFill>
               </a:rPr>
-              <a:t>3</a:t>
-            </a:r>
-            <a:endParaRPr sz="1250">
-              <a:latin typeface="Trebuchet MS"/>
-              <a:ea typeface="Trebuchet MS"/>
-              <a:cs typeface="Trebuchet MS"/>
-              <a:sym typeface="Trebuchet MS"/>
-            </a:endParaRPr>
+              <a:t>Pipeline A — Baseline</a:t>
+            </a:r>
+          </a:p>
+          <a:p>
+            <a:pPr algn="ctr">
+              <a:spcBef>
+                <a:spcPts val="100"/>
+              </a:spcBef>
+            </a:pPr>
+            <a:r>
+              <a:rPr lang="en-US" sz="1300" i="1" dirty="0"/>
+              <a:t>Fixed-Size Character Chunking</a:t>
+            </a:r>
+          </a:p>
+          <a:p>
+            <a:pPr algn="l">
+              <a:spcBef>
+                <a:spcPts val="300"/>
+              </a:spcBef>
+            </a:pPr>
+            <a:r>
+              <a:rPr lang="en-US" sz="1400" b="1" dirty="0"/>
+              <a:t>Splitter: </a:t>
+            </a:r>
+            <a:r>
+              <a:rPr lang="en-US" sz="1400" dirty="0"/>
+              <a:t>RecursiveCharacterTextSplitter</a:t>
+            </a:r>
+          </a:p>
+          <a:p>
+            <a:pPr algn="l">
+              <a:spcBef>
+                <a:spcPts val="200"/>
+              </a:spcBef>
+            </a:pPr>
+            <a:r>
+              <a:rPr lang="en-US" sz="1400" b="1" dirty="0"/>
+              <a:t>Chunks produced: </a:t>
+            </a:r>
+            <a:r>
+              <a:rPr lang="en-US" sz="1400" dirty="0"/>
+              <a:t>804</a:t>
+            </a:r>
+          </a:p>
+          <a:p>
+            <a:pPr algn="l">
+              <a:spcBef>
+                <a:spcPts val="200"/>
+              </a:spcBef>
+            </a:pPr>
+            <a:r>
+              <a:rPr lang="en-US" sz="1400" b="1" dirty="0"/>
+              <a:t>Split logic: </a:t>
+            </a:r>
+            <a:r>
+              <a:rPr lang="en-US" sz="1400" dirty="0"/>
+              <a:t>cᵢ = S[k : k + chunk_size] where k is an arbitrary character offset. Tries paragraph/newline/whitespace breaks; falls back to character cut.</a:t>
+            </a:r>
+          </a:p>
+          <a:p>
+            <a:pPr algn="l">
+              <a:spcBef>
+                <a:spcPts val="200"/>
+              </a:spcBef>
+            </a:pPr>
+            <a:r>
+              <a:rPr lang="en-US" sz="1400" b="1" dirty="0"/>
+              <a:t>Code awareness: </a:t>
+            </a:r>
+            <a:r>
+              <a:rPr lang="en-US" sz="1400" dirty="0"/>
+              <a:t>None — ignores Python syntax entirely.</a:t>
+            </a:r>
+          </a:p>
+          <a:p>
+            <a:pPr algn="l">
+              <a:spcBef>
+                <a:spcPts val="300"/>
+              </a:spcBef>
+            </a:pPr>
+            <a:r>
+              <a:rPr lang="en-US" sz="1400" b="1" dirty="0"/>
+              <a:t>Drawback: </a:t>
+            </a:r>
+            <a:r>
+              <a:rPr lang="en-US" sz="1400" dirty="0"/>
+              <a:t>Frequently bisects function bodies and class definitions, merging logically distinct code units to fill character quotas.</a:t>
+            </a:r>
+          </a:p>
+          <a:p>
+            <a:pPr algn="l">
+              <a:spcBef>
+                <a:spcPts val="300"/>
+              </a:spcBef>
+            </a:pPr>
+            <a:r>
+              <a:rPr lang="en-US" sz="1400" b="1" dirty="0"/>
+              <a:t>Result: </a:t>
+            </a:r>
+            <a:r>
+              <a:rPr lang="en-US" sz="1400" dirty="0"/>
+              <a:t>Boundary alignment is </a:t>
+            </a:r>
+            <a:r>
+              <a:rPr lang="en-US" sz="1400" b="1" dirty="0">
+                <a:solidFill>
+                  <a:srgbClr val="CC0000"/>
+                </a:solidFill>
+              </a:rPr>
+              <a:t>incidental</a:t>
+            </a:r>
+            <a:r>
+              <a:rPr lang="en-US" sz="1400" dirty="0"/>
+              <a:t> — correct only when a function happens to coincide with a character-count boundary.</a:t>
+            </a:r>
+          </a:p>
+        </p:txBody>
+      </p:sp>
+      <p:sp>
+        <p:nvSpPr>
+          <p:cNvPr id="101" name="PipelineB"/>
+          <p:cNvSpPr txBox="1"/>
+          <p:nvPr/>
+        </p:nvSpPr>
+        <p:spPr>
+          <a:xfrm>
+            <a:off x="4876800" y="1001948"/>
+            <a:ext cx="3725694" cy="4929555"/>
+          </a:xfrm>
+          <a:prstGeom prst="rect">
+            <a:avLst/>
+          </a:prstGeom>
+          <a:solidFill>
+            <a:srgbClr val="F0FFF0"/>
+          </a:solidFill>
+          <a:ln w="19050">
+            <a:solidFill>
+              <a:srgbClr val="227722"/>
+            </a:solidFill>
+          </a:ln>
+        </p:spPr>
+        <p:txBody>
+          <a:bodyPr wrap="square" lIns="182880" tIns="182880" rIns="182880" bIns="182880" anchor="t">
+            <a:spAutoFit/>
+          </a:bodyPr>
+          <a:lstStyle/>
+          <a:p>
+            <a:pPr algn="ctr">
+              <a:spcBef>
+                <a:spcPts val="0"/>
+              </a:spcBef>
+            </a:pPr>
+            <a:r>
+              <a:rPr lang="en-US" sz="1800" b="1" dirty="0">
+                <a:solidFill>
+                  <a:srgbClr val="227722"/>
+                </a:solidFill>
+              </a:rPr>
+              <a:t>Pipeline B — Proposed</a:t>
+            </a:r>
+          </a:p>
+          <a:p>
+            <a:pPr algn="ctr">
+              <a:spcBef>
+                <a:spcPts val="100"/>
+              </a:spcBef>
+            </a:pPr>
+            <a:r>
+              <a:rPr lang="en-US" sz="1300" i="1" dirty="0"/>
+              <a:t>AST-Aware Semantic Chunking</a:t>
+            </a:r>
+          </a:p>
+          <a:p>
+            <a:pPr algn="l">
+              <a:spcBef>
+                <a:spcPts val="300"/>
+              </a:spcBef>
+            </a:pPr>
+            <a:r>
+              <a:rPr lang="en-US" sz="1400" b="1" dirty="0"/>
+              <a:t>Splitter: </a:t>
+            </a:r>
+            <a:r>
+              <a:rPr lang="en-US" sz="1400" dirty="0"/>
+              <a:t>RecursiveCharacterTextSplitter.from_language(Language.PYTHON)</a:t>
+            </a:r>
+          </a:p>
+          <a:p>
+            <a:pPr algn="l">
+              <a:spcBef>
+                <a:spcPts val="200"/>
+              </a:spcBef>
+            </a:pPr>
+            <a:r>
+              <a:rPr lang="en-US" sz="1400" b="1" dirty="0"/>
+              <a:t>Chunks produced: </a:t>
+            </a:r>
+            <a:r>
+              <a:rPr lang="en-US" sz="1400" dirty="0"/>
+              <a:t>861 (+7.1% vs. baseline)</a:t>
+            </a:r>
+          </a:p>
+          <a:p>
+            <a:pPr algn="l">
+              <a:spcBef>
+                <a:spcPts val="200"/>
+              </a:spcBef>
+            </a:pPr>
+            <a:r>
+              <a:rPr lang="en-US" sz="1400" b="1" dirty="0"/>
+              <a:t>Split hierarchy: </a:t>
+            </a:r>
+            <a:r>
+              <a:rPr lang="en-US" sz="1400" dirty="0"/>
+              <a:t>(1) class definitions → (2) function defs → (3) blank lines → (4) single newlines → (5) character level.</a:t>
+            </a:r>
+          </a:p>
+          <a:p>
+            <a:pPr algn="l">
+              <a:spcBef>
+                <a:spcPts val="200"/>
+              </a:spcBef>
+            </a:pPr>
+            <a:r>
+              <a:rPr lang="en-US" sz="1400" b="1" dirty="0"/>
+              <a:t>Formal: </a:t>
+            </a:r>
+            <a:r>
+              <a:rPr lang="en-US" sz="1400" dirty="0"/>
+              <a:t>cⱼ = AST_node(f), f ∈ {class_def, func_def, method_def}</a:t>
+            </a:r>
+          </a:p>
+          <a:p>
+            <a:pPr algn="l">
+              <a:spcBef>
+                <a:spcPts val="300"/>
+              </a:spcBef>
+            </a:pPr>
+            <a:r>
+              <a:rPr lang="en-US" sz="1400" b="1" dirty="0"/>
+              <a:t>Key advantage: </a:t>
+            </a:r>
+            <a:r>
+              <a:rPr lang="en-US" sz="1400" dirty="0"/>
+              <a:t>Each function node encapsulates its complete body, decorators, signature, and docstring — exactly what an LLM needs to understand context.</a:t>
+            </a:r>
+          </a:p>
+          <a:p>
+            <a:pPr algn="l">
+              <a:spcBef>
+                <a:spcPts val="300"/>
+              </a:spcBef>
+            </a:pPr>
+            <a:r>
+              <a:rPr lang="en-US" sz="1400" b="1" dirty="0"/>
+              <a:t>Result: </a:t>
+            </a:r>
+            <a:r>
+              <a:rPr lang="en-US" sz="1400" dirty="0"/>
+              <a:t>Boundary alignment is </a:t>
+            </a:r>
+            <a:r>
+              <a:rPr lang="en-US" sz="1400" b="1" dirty="0">
+                <a:solidFill>
+                  <a:srgbClr val="227722"/>
+                </a:solidFill>
+              </a:rPr>
+              <a:t>consistent by construction</a:t>
+            </a:r>
+            <a:r>
+              <a:rPr lang="en-US" sz="1400" dirty="0"/>
+              <a:t> — every chunk starts at a class or function definition.</a:t>
+            </a:r>
+          </a:p>
+        </p:txBody>
+      </p:sp>
+    </p:spTree>
+  </p:cSld>
+  <p:clrMapOvr>
+    <a:masterClrMapping/>
+  </p:clrMapOvr>
+</p:sld>
+</file>
+
+<file path=ppt/slides/slide8.xml><?xml version="1.0" encoding="utf-8"?>
+<p:sld xmlns:a="http://schemas.openxmlformats.org/drawingml/2006/main" xmlns:r="http://schemas.openxmlformats.org/officeDocument/2006/relationships" xmlns:p="http://schemas.openxmlformats.org/presentationml/2006/main">
+  <p:cSld>
+    <p:spTree>
+      <p:nvGrpSpPr>
+        <p:cNvPr id="1" name="Shape 1"/>
+        <p:cNvGrpSpPr/>
+        <p:nvPr/>
+      </p:nvGrpSpPr>
+      <p:grpSpPr>
+        <a:xfrm>
+          <a:off x="0" y="0"/>
+          <a:ext cx="0" cy="0"/>
+          <a:chOff x="0" y="0"/>
+          <a:chExt cx="0" cy="0"/>
+        </a:xfrm>
+      </p:grpSpPr>
+      <p:sp>
+        <p:nvSpPr>
+          <p:cNvPr id="2" name="Title"/>
+          <p:cNvSpPr txBox="1">
+            <a:spLocks noGrp="1"/>
+          </p:cNvSpPr>
+          <p:nvPr>
+            <p:ph type="title"/>
+          </p:nvPr>
+        </p:nvSpPr>
+        <p:spPr>
+          <a:xfrm>
+            <a:off x="-387625" y="109377"/>
+            <a:ext cx="5889474" cy="537306"/>
+          </a:xfrm>
+          <a:prstGeom prst="rect">
+            <a:avLst/>
+          </a:prstGeom>
+          <a:noFill/>
+          <a:ln>
+            <a:noFill/>
+          </a:ln>
+        </p:spPr>
+        <p:txBody>
+          <a:bodyPr spcFirstLastPara="1" wrap="square" lIns="0" tIns="13950" rIns="0" bIns="0" anchor="t" anchorCtr="0">
+            <a:spAutoFit/>
+          </a:bodyPr>
+          <a:lstStyle/>
+          <a:p>
+            <a:pPr marL="601980" lvl="0" indent="0" algn="l" rtl="0">
+              <a:lnSpc>
+                <a:spcPct val="100000"/>
+              </a:lnSpc>
+              <a:spcBef>
+                <a:spcPts val="0"/>
+              </a:spcBef>
+              <a:spcAft>
+                <a:spcPts val="0"/>
+              </a:spcAft>
+              <a:buNone/>
+            </a:pPr>
+            <a:r>
+              <a:rPr lang="en-US"/>
+              <a:t>Results &amp; Discussion</a:t>
+            </a:r>
+          </a:p>
+        </p:txBody>
+      </p:sp>
+      <p:sp>
+        <p:nvSpPr>
+          <p:cNvPr id="3" name="Footer"/>
+          <p:cNvSpPr txBox="1">
+            <a:spLocks noGrp="1"/>
+          </p:cNvSpPr>
+          <p:nvPr>
+            <p:ph type="ftr" idx="11"/>
+          </p:nvPr>
+        </p:nvSpPr>
+        <p:spPr>
+          <a:xfrm>
+            <a:off x="9076876" y="6801811"/>
+            <a:ext cx="110490" cy="220979"/>
+          </a:xfrm>
+          <a:prstGeom prst="rect">
+            <a:avLst/>
+          </a:prstGeom>
+          <a:noFill/>
+          <a:ln>
+            <a:noFill/>
+          </a:ln>
+        </p:spPr>
+        <p:txBody>
+          <a:bodyPr spcFirstLastPara="1" wrap="square" lIns="0" tIns="8250" rIns="0" bIns="0" anchor="t" anchorCtr="0">
+            <a:spAutoFit/>
+          </a:bodyPr>
+          <a:lstStyle/>
+          <a:p>
+            <a:pPr marL="12700" lvl="0" indent="0" algn="l" rtl="0">
+              <a:lnSpc>
+                <a:spcPct val="100000"/>
+              </a:lnSpc>
+              <a:spcBef>
+                <a:spcPts val="0"/>
+              </a:spcBef>
+              <a:spcAft>
+                <a:spcPts val="0"/>
+              </a:spcAft>
+              <a:buNone/>
+            </a:pPr>
+            <a:r>
+              <a:rPr lang="en-US"/>
+              <a:t>8</a:t>
+            </a:r>
+          </a:p>
+        </p:txBody>
+      </p:sp>
+      <p:sp>
+        <p:nvSpPr>
+          <p:cNvPr id="100" name="LeftStats"/>
+          <p:cNvSpPr txBox="1"/>
+          <p:nvPr/>
+        </p:nvSpPr>
+        <p:spPr>
+          <a:xfrm>
+            <a:off x="453600" y="993192"/>
+            <a:ext cx="3544468" cy="2069797"/>
+          </a:xfrm>
+          <a:prstGeom prst="rect">
+            <a:avLst/>
+          </a:prstGeom>
+          <a:noFill/>
+          <a:ln>
+            <a:noFill/>
+          </a:ln>
+        </p:spPr>
+        <p:txBody>
+          <a:bodyPr wrap="square" lIns="91440" tIns="45720" rIns="91440" bIns="45720" anchor="t">
+            <a:spAutoFit/>
+          </a:bodyPr>
+          <a:lstStyle/>
+          <a:p>
+            <a:pPr algn="l">
+              <a:spcBef>
+                <a:spcPts val="0"/>
+              </a:spcBef>
+            </a:pPr>
+            <a:r>
+              <a:rPr lang="en-US" sz="1800" b="1" dirty="0">
+                <a:solidFill>
+                  <a:srgbClr val="CC0000"/>
+                </a:solidFill>
+              </a:rPr>
+              <a:t>Chunk Statistics Comparison</a:t>
+            </a:r>
+          </a:p>
+          <a:p>
+            <a:pPr algn="l">
+              <a:spcBef>
+                <a:spcPts val="250"/>
+              </a:spcBef>
+            </a:pPr>
+            <a:r>
+              <a:rPr lang="en-US" sz="1400" dirty="0"/>
+              <a:t>Source files (both): </a:t>
+            </a:r>
+            <a:r>
+              <a:rPr lang="en-US" sz="1400" b="1" dirty="0"/>
+              <a:t>83 .py files</a:t>
+            </a:r>
+          </a:p>
+          <a:p>
+            <a:pPr algn="l">
+              <a:spcBef>
+                <a:spcPts val="200"/>
+              </a:spcBef>
+            </a:pPr>
+            <a:r>
+              <a:rPr lang="en-US" sz="1400" dirty="0"/>
+              <a:t>Pipeline A chunks: </a:t>
+            </a:r>
+            <a:r>
+              <a:rPr lang="en-US" sz="1400" b="1" dirty="0">
+                <a:solidFill>
+                  <a:srgbClr val="CC0000"/>
+                </a:solidFill>
+              </a:rPr>
+              <a:t>804</a:t>
+            </a:r>
+          </a:p>
+          <a:p>
+            <a:pPr algn="l">
+              <a:spcBef>
+                <a:spcPts val="200"/>
+              </a:spcBef>
+            </a:pPr>
+            <a:r>
+              <a:rPr lang="en-US" sz="1400" dirty="0"/>
+              <a:t>Pipeline B chunks: </a:t>
+            </a:r>
+            <a:r>
+              <a:rPr lang="en-US" sz="1400" b="1" dirty="0">
+                <a:solidFill>
+                  <a:srgbClr val="227722"/>
+                </a:solidFill>
+              </a:rPr>
+              <a:t>861 (+7.1%)</a:t>
+            </a:r>
+          </a:p>
+          <a:p>
+            <a:pPr algn="l">
+              <a:spcBef>
+                <a:spcPts val="200"/>
+              </a:spcBef>
+            </a:pPr>
+            <a:r>
+              <a:rPr lang="en-US" sz="1400" dirty="0"/>
+              <a:t>Critical query failures A: </a:t>
+            </a:r>
+            <a:r>
+              <a:rPr lang="en-US" sz="1400" b="1" dirty="0">
+                <a:solidFill>
+                  <a:srgbClr val="CC0000"/>
+                </a:solidFill>
+              </a:rPr>
+              <a:t>4 documented</a:t>
+            </a:r>
+          </a:p>
+          <a:p>
+            <a:pPr algn="l">
+              <a:spcBef>
+                <a:spcPts val="200"/>
+              </a:spcBef>
+            </a:pPr>
+            <a:r>
+              <a:rPr lang="en-US" sz="1400" dirty="0"/>
+              <a:t>Critical query failures B: </a:t>
+            </a:r>
+            <a:r>
+              <a:rPr lang="en-US" sz="1400" b="1" dirty="0">
+                <a:solidFill>
+                  <a:srgbClr val="227722"/>
+                </a:solidFill>
+              </a:rPr>
+              <a:t>0</a:t>
+            </a:r>
+          </a:p>
+          <a:p>
+            <a:pPr algn="l">
+              <a:spcBef>
+                <a:spcPts val="200"/>
+              </a:spcBef>
+            </a:pPr>
+            <a:r>
+              <a:rPr lang="en-US" sz="1400" dirty="0"/>
+              <a:t>Boundary retrieval A: </a:t>
+            </a:r>
+            <a:r>
+              <a:rPr lang="en-US" sz="1400" b="1" dirty="0">
+                <a:solidFill>
+                  <a:srgbClr val="CC0000"/>
+                </a:solidFill>
+              </a:rPr>
+              <a:t>Incidental</a:t>
+            </a:r>
+          </a:p>
+          <a:p>
+            <a:pPr algn="l">
+              <a:spcBef>
+                <a:spcPts val="200"/>
+              </a:spcBef>
+            </a:pPr>
+            <a:r>
+              <a:rPr lang="en-US" sz="1400" dirty="0"/>
+              <a:t>Boundary retrieval B: </a:t>
+            </a:r>
+            <a:r>
+              <a:rPr lang="en-US" sz="1400" b="1" dirty="0">
+                <a:solidFill>
+                  <a:srgbClr val="227722"/>
+                </a:solidFill>
+              </a:rPr>
+              <a:t>Consistent</a:t>
+            </a:r>
+          </a:p>
+        </p:txBody>
+      </p:sp>
+      <p:sp>
+        <p:nvSpPr>
+          <p:cNvPr id="101" name="RightAggregates"/>
+          <p:cNvSpPr txBox="1"/>
+          <p:nvPr/>
+        </p:nvSpPr>
+        <p:spPr>
+          <a:xfrm>
+            <a:off x="4937762" y="1073533"/>
+            <a:ext cx="4319438" cy="2341667"/>
+          </a:xfrm>
+          <a:prstGeom prst="rect">
+            <a:avLst/>
+          </a:prstGeom>
+          <a:noFill/>
+          <a:ln>
+            <a:noFill/>
+          </a:ln>
+        </p:spPr>
+        <p:txBody>
+          <a:bodyPr wrap="square" lIns="91440" tIns="45720" rIns="91440" bIns="45720" anchor="t">
+            <a:spAutoFit/>
+          </a:bodyPr>
+          <a:lstStyle/>
+          <a:p>
+            <a:pPr algn="l">
+              <a:spcBef>
+                <a:spcPts val="0"/>
+              </a:spcBef>
+            </a:pPr>
+            <a:r>
+              <a:rPr lang="en-US" sz="1800" b="1" dirty="0">
+                <a:solidFill>
+                  <a:srgbClr val="CC0000"/>
+                </a:solidFill>
+              </a:rPr>
+              <a:t>Aggregate Score (20 Queries)</a:t>
+            </a:r>
+          </a:p>
+          <a:p>
+            <a:pPr algn="ctr">
+              <a:spcBef>
+                <a:spcPts val="300"/>
+              </a:spcBef>
+            </a:pPr>
+            <a:r>
+              <a:rPr lang="en-US" sz="4800" b="1" dirty="0">
+                <a:solidFill>
+                  <a:srgbClr val="CC0000"/>
+                </a:solidFill>
+              </a:rPr>
+              <a:t>28</a:t>
+            </a:r>
+            <a:r>
+              <a:rPr lang="en-US" sz="2000" dirty="0">
+                <a:solidFill>
+                  <a:srgbClr val="CC0000"/>
+                </a:solidFill>
+              </a:rPr>
+              <a:t>/40</a:t>
+            </a:r>
+          </a:p>
+          <a:p>
+            <a:pPr algn="ctr">
+              <a:spcBef>
+                <a:spcPts val="0"/>
+              </a:spcBef>
+            </a:pPr>
+            <a:r>
+              <a:rPr lang="en-US" sz="1400" dirty="0">
+                <a:solidFill>
+                  <a:srgbClr val="CC0000"/>
+                </a:solidFill>
+              </a:rPr>
+              <a:t>Pipeline A (70%)</a:t>
+            </a:r>
+          </a:p>
+          <a:p>
+            <a:pPr algn="ctr">
+              <a:spcBef>
+                <a:spcPts val="200"/>
+              </a:spcBef>
+            </a:pPr>
+            <a:r>
+              <a:rPr lang="en-US" sz="4800" b="1" dirty="0">
+                <a:solidFill>
+                  <a:srgbClr val="227722"/>
+                </a:solidFill>
+              </a:rPr>
+              <a:t>40</a:t>
+            </a:r>
+            <a:r>
+              <a:rPr lang="en-US" sz="2000" dirty="0">
+                <a:solidFill>
+                  <a:srgbClr val="227722"/>
+                </a:solidFill>
+              </a:rPr>
+              <a:t>/40</a:t>
+            </a:r>
+          </a:p>
+          <a:p>
+            <a:pPr algn="ctr">
+              <a:spcBef>
+                <a:spcPts val="0"/>
+              </a:spcBef>
+            </a:pPr>
+            <a:r>
+              <a:rPr lang="en-US" sz="1400" dirty="0">
+                <a:solidFill>
+                  <a:srgbClr val="227722"/>
+                </a:solidFill>
+              </a:rPr>
+              <a:t>Pipeline B (100%)</a:t>
+            </a:r>
+          </a:p>
+        </p:txBody>
+      </p:sp>
+      <p:sp>
+        <p:nvSpPr>
+          <p:cNvPr id="102" name="Discussion"/>
+          <p:cNvSpPr txBox="1"/>
+          <p:nvPr/>
+        </p:nvSpPr>
+        <p:spPr>
+          <a:xfrm>
+            <a:off x="457200" y="3900000"/>
+            <a:ext cx="8800000" cy="2900000"/>
+          </a:xfrm>
+          <a:prstGeom prst="rect">
+            <a:avLst/>
+          </a:prstGeom>
+          <a:solidFill>
+            <a:srgbClr val="F5F5F5"/>
+          </a:solidFill>
+          <a:ln w="12700">
+            <a:solidFill>
+              <a:srgbClr val="DDDDDD"/>
+            </a:solidFill>
+          </a:ln>
+        </p:spPr>
+        <p:txBody>
+          <a:bodyPr wrap="square" lIns="182880" tIns="182880" rIns="182880" bIns="182880" anchor="t">
+            <a:spAutoFit/>
+          </a:bodyPr>
+          <a:lstStyle/>
+          <a:p>
+            <a:pPr algn="l">
+              <a:spcBef>
+                <a:spcPts val="0"/>
+              </a:spcBef>
+            </a:pPr>
+            <a:r>
+              <a:rPr lang="en-US" sz="1600" b="1" dirty="0">
+                <a:solidFill>
+                  <a:srgbClr val="CC0000"/>
+                </a:solidFill>
+              </a:rPr>
+              <a:t>Key Discussion Points</a:t>
+            </a:r>
+          </a:p>
+          <a:p>
+            <a:pPr marL="228600" indent="-228600" algn="l">
+              <a:spcBef>
+                <a:spcPts val="200"/>
+              </a:spcBef>
+              <a:buChar char="•"/>
+            </a:pPr>
+            <a:r>
+              <a:rPr lang="en-US" sz="1400" dirty="0"/>
+              <a:t>The 57-chunk increase (+7.1%) reflects the AST splitter’s refusal to merge semantically distinct code units just to fill a 1,000-character limit. Each extra chunk represents a code unit that would have been improperly merged in the baseline.</a:t>
+            </a:r>
+          </a:p>
+          <a:p>
+            <a:pPr marL="228600" indent="-228600" algn="l">
+              <a:spcBef>
+                <a:spcPts val="200"/>
+              </a:spcBef>
+              <a:buChar char="•"/>
+            </a:pPr>
+            <a:r>
+              <a:rPr lang="en-US" sz="1400" dirty="0"/>
+              <a:t>Smaller, semantically consistent chunks improve embedding precision — each vector represents an increasingly specific semantic unit. Aligns with Wang et al. [3] who found 200–800 token chunks enable better retrieval.</a:t>
+            </a:r>
+          </a:p>
+          <a:p>
+            <a:pPr marL="228600" indent="-228600" algn="l">
+              <a:spcBef>
+                <a:spcPts val="200"/>
+              </a:spcBef>
+              <a:buChar char="•"/>
+            </a:pPr>
+            <a:r>
+              <a:rPr lang="en-US" sz="1400" dirty="0"/>
+              <a:t>The only cost is a negligible storage/indexing overhead for 57 extra chunks — no additional dependencies beyond standard LangChain, making it a zero-cost drop-in upgrade.</a:t>
+            </a:r>
+          </a:p>
+        </p:txBody>
+      </p:sp>
+    </p:spTree>
+  </p:cSld>
+  <p:clrMapOvr>
+    <a:masterClrMapping/>
+  </p:clrMapOvr>
+</p:sld>
+</file>
+
+<file path=ppt/slides/slide9.xml><?xml version="1.0" encoding="utf-8"?>
+<p:sld xmlns:a="http://schemas.openxmlformats.org/drawingml/2006/main" xmlns:r="http://schemas.openxmlformats.org/officeDocument/2006/relationships" xmlns:p="http://schemas.openxmlformats.org/presentationml/2006/main">
+  <p:cSld>
+    <p:spTree>
+      <p:nvGrpSpPr>
+        <p:cNvPr id="1" name="Shape 1"/>
+        <p:cNvGrpSpPr/>
+        <p:nvPr/>
+      </p:nvGrpSpPr>
+      <p:grpSpPr>
+        <a:xfrm>
+          <a:off x="0" y="0"/>
+          <a:ext cx="0" cy="0"/>
+          <a:chOff x="0" y="0"/>
+          <a:chExt cx="0" cy="0"/>
+        </a:xfrm>
+      </p:grpSpPr>
+      <p:sp>
+        <p:nvSpPr>
+          <p:cNvPr id="2" name="Title"/>
+          <p:cNvSpPr txBox="1">
+            <a:spLocks noGrp="1"/>
+          </p:cNvSpPr>
+          <p:nvPr>
+            <p:ph type="title"/>
+          </p:nvPr>
+        </p:nvSpPr>
+        <p:spPr>
+          <a:xfrm>
+            <a:off x="-387625" y="109377"/>
+            <a:ext cx="7051072" cy="537306"/>
+          </a:xfrm>
+          <a:prstGeom prst="rect">
+            <a:avLst/>
+          </a:prstGeom>
+          <a:noFill/>
+          <a:ln>
+            <a:noFill/>
+          </a:ln>
+        </p:spPr>
+        <p:txBody>
+          <a:bodyPr spcFirstLastPara="1" wrap="square" lIns="0" tIns="13950" rIns="0" bIns="0" anchor="t" anchorCtr="0">
+            <a:spAutoFit/>
+          </a:bodyPr>
+          <a:lstStyle/>
+          <a:p>
+            <a:pPr marL="601980" lvl="0" indent="0" algn="l" rtl="0">
+              <a:lnSpc>
+                <a:spcPct val="100000"/>
+              </a:lnSpc>
+              <a:spcBef>
+                <a:spcPts val="0"/>
+              </a:spcBef>
+              <a:spcAft>
+                <a:spcPts val="0"/>
+              </a:spcAft>
+              <a:buNone/>
+            </a:pPr>
+            <a:r>
+              <a:rPr lang="en-US" dirty="0"/>
+              <a:t>Critical Failure Modes in Pipeline A</a:t>
+            </a:r>
+          </a:p>
+        </p:txBody>
+      </p:sp>
+      <p:sp>
+        <p:nvSpPr>
+          <p:cNvPr id="3" name="Footer"/>
+          <p:cNvSpPr txBox="1">
+            <a:spLocks noGrp="1"/>
+          </p:cNvSpPr>
+          <p:nvPr>
+            <p:ph type="ftr" idx="11"/>
+          </p:nvPr>
+        </p:nvSpPr>
+        <p:spPr>
+          <a:xfrm>
+            <a:off x="9076876" y="6801811"/>
+            <a:ext cx="110490" cy="220979"/>
+          </a:xfrm>
+          <a:prstGeom prst="rect">
+            <a:avLst/>
+          </a:prstGeom>
+          <a:noFill/>
+          <a:ln>
+            <a:noFill/>
+          </a:ln>
+        </p:spPr>
+        <p:txBody>
+          <a:bodyPr spcFirstLastPara="1" wrap="square" lIns="0" tIns="8250" rIns="0" bIns="0" anchor="t" anchorCtr="0">
+            <a:spAutoFit/>
+          </a:bodyPr>
+          <a:lstStyle/>
+          <a:p>
+            <a:pPr marL="12700" lvl="0" indent="0" algn="l" rtl="0">
+              <a:lnSpc>
+                <a:spcPct val="100000"/>
+              </a:lnSpc>
+              <a:spcBef>
+                <a:spcPts val="0"/>
+              </a:spcBef>
+              <a:spcAft>
+                <a:spcPts val="0"/>
+              </a:spcAft>
+              <a:buNone/>
+            </a:pPr>
+            <a:r>
+              <a:rPr lang="en-US"/>
+              <a:t>9</a:t>
+            </a:r>
+          </a:p>
+        </p:txBody>
+      </p:sp>
+      <p:sp>
+        <p:nvSpPr>
+          <p:cNvPr id="100" name="ContentBox"/>
+          <p:cNvSpPr txBox="1"/>
+          <p:nvPr/>
+        </p:nvSpPr>
+        <p:spPr>
+          <a:xfrm>
+            <a:off x="276876" y="1039906"/>
+            <a:ext cx="8800000" cy="6100000"/>
+          </a:xfrm>
+          <a:prstGeom prst="rect">
+            <a:avLst/>
+          </a:prstGeom>
+          <a:noFill/>
+          <a:ln>
+            <a:noFill/>
+          </a:ln>
+        </p:spPr>
+        <p:txBody>
+          <a:bodyPr wrap="square" lIns="91440" tIns="45720" rIns="91440" bIns="45720" anchor="t">
+            <a:spAutoFit/>
+          </a:bodyPr>
+          <a:lstStyle/>
+          <a:p>
+            <a:pPr algn="l">
+              <a:spcBef>
+                <a:spcPts val="0"/>
+              </a:spcBef>
+            </a:pPr>
+            <a:r>
+              <a:rPr lang="en-US" sz="1500" dirty="0"/>
+              <a:t>Four cases where Pipeline A returned qualitatively incorrect results. Pipeline B resolved all four by design:</a:t>
+            </a:r>
+          </a:p>
+          <a:p>
+            <a:pPr algn="l">
+              <a:spcBef>
+                <a:spcPts val="350"/>
+              </a:spcBef>
+            </a:pPr>
+            <a:r>
+              <a:rPr lang="en-US" sz="1600" b="1" dirty="0">
+                <a:solidFill>
+                  <a:srgbClr val="CC0000"/>
+                </a:solidFill>
+              </a:rPr>
+              <a:t>F1 — Keyword Blindness: copy_current_request_context</a:t>
+            </a:r>
+          </a:p>
+          <a:p>
+            <a:pPr algn="l">
+              <a:spcBef>
+                <a:spcPts val="100"/>
+              </a:spcBef>
+            </a:pPr>
+            <a:r>
+              <a:rPr lang="en-US" sz="1400" b="1" dirty="0"/>
+              <a:t>Pipeline A: </a:t>
+            </a:r>
+            <a:r>
+              <a:rPr lang="en-US" sz="1400" dirty="0"/>
+              <a:t>Retrieved def copy(self) — WRONG function. Fixed-size chunk merged both functions; shorter copy(self) was more keyword-dense, diluting the embedding for the intended target.</a:t>
+            </a:r>
+          </a:p>
+          <a:p>
+            <a:pPr algn="l">
+              <a:spcBef>
+                <a:spcPts val="100"/>
+              </a:spcBef>
+            </a:pPr>
+            <a:r>
+              <a:rPr lang="en-US" sz="1400" b="1" dirty="0">
+                <a:solidFill>
+                  <a:srgbClr val="227722"/>
+                </a:solidFill>
+              </a:rPr>
+              <a:t>Pipeline B: </a:t>
+            </a:r>
+            <a:r>
+              <a:rPr lang="en-US" sz="1400" dirty="0"/>
+              <a:t>Each function isolated in its own chunk — exact copy_current_request_context(f:F) retrieved.</a:t>
+            </a:r>
+          </a:p>
+          <a:p>
+            <a:pPr algn="l">
+              <a:spcBef>
+                <a:spcPts val="300"/>
+              </a:spcBef>
+            </a:pPr>
+            <a:r>
+              <a:rPr lang="en-US" sz="1600" b="1" dirty="0">
+                <a:solidFill>
+                  <a:srgbClr val="CC0000"/>
+                </a:solidFill>
+              </a:rPr>
+              <a:t>F2 — Context Fragmentation: _AppCtxGlobals class</a:t>
+            </a:r>
+          </a:p>
+          <a:p>
+            <a:pPr algn="l">
+              <a:spcBef>
+                <a:spcPts val="100"/>
+              </a:spcBef>
+            </a:pPr>
+            <a:r>
+              <a:rPr lang="en-US" sz="1400" b="1" dirty="0"/>
+              <a:t>Pipeline A: </a:t>
+            </a:r>
+            <a:r>
+              <a:rPr lang="en-US" sz="1400" dirty="0"/>
+              <a:t>Mid-docstring fragment; class definition missing entirely — useless for an LLM needing class context.</a:t>
+            </a:r>
+          </a:p>
+          <a:p>
+            <a:pPr algn="l">
+              <a:spcBef>
+                <a:spcPts val="100"/>
+              </a:spcBef>
+            </a:pPr>
+            <a:r>
+              <a:rPr lang="en-US" sz="1400" b="1" dirty="0">
+                <a:solidFill>
+                  <a:srgbClr val="227722"/>
+                </a:solidFill>
+              </a:rPr>
+              <a:t>Pipeline B: </a:t>
+            </a:r>
+            <a:r>
+              <a:rPr lang="en-US" sz="1400" dirty="0"/>
+              <a:t>class _AppCtxGlobals: retrieved with full docstring from the class definition boundary.</a:t>
+            </a:r>
+          </a:p>
+          <a:p>
+            <a:pPr algn="l">
+              <a:spcBef>
+                <a:spcPts val="300"/>
+              </a:spcBef>
+            </a:pPr>
+            <a:r>
+              <a:rPr lang="en-US" sz="1600" b="1" dirty="0">
+                <a:solidFill>
+                  <a:srgbClr val="CC0000"/>
+                </a:solidFill>
+              </a:rPr>
+              <a:t>F3 — Context Fragmentation: has_request_context()</a:t>
+            </a:r>
+          </a:p>
+          <a:p>
+            <a:pPr algn="l">
+              <a:spcBef>
+                <a:spcPts val="100"/>
+              </a:spcBef>
+            </a:pPr>
+            <a:r>
+              <a:rPr lang="en-US" sz="1400" b="1" dirty="0"/>
+              <a:t>Pipeline A: </a:t>
+            </a:r>
+            <a:r>
+              <a:rPr lang="en-US" sz="1400" dirty="0"/>
+              <a:t>Bottom half of docstring only; no signature — the LLM cannot determine what function this belongs to.</a:t>
+            </a:r>
+          </a:p>
+          <a:p>
+            <a:pPr algn="l">
+              <a:spcBef>
+                <a:spcPts val="100"/>
+              </a:spcBef>
+            </a:pPr>
+            <a:r>
+              <a:rPr lang="en-US" sz="1400" b="1" dirty="0">
+                <a:solidFill>
+                  <a:srgbClr val="227722"/>
+                </a:solidFill>
+              </a:rPr>
+              <a:t>Pipeline B: </a:t>
+            </a:r>
+            <a:r>
+              <a:rPr lang="en-US" sz="1400" dirty="0"/>
+              <a:t>def has_request_context() -&gt; bool: with full signature and usage example code block.</a:t>
+            </a:r>
+          </a:p>
+          <a:p>
+            <a:pPr algn="l">
+              <a:spcBef>
+                <a:spcPts val="300"/>
+              </a:spcBef>
+            </a:pPr>
+            <a:r>
+              <a:rPr lang="en-US" sz="1600" b="1" dirty="0">
+                <a:solidFill>
+                  <a:srgbClr val="CC0000"/>
+                </a:solidFill>
+              </a:rPr>
+              <a:t>F4 — Context Fragmentation: ConfigAttribute descriptor</a:t>
+            </a:r>
+          </a:p>
+          <a:p>
+            <a:pPr algn="l">
+              <a:spcBef>
+                <a:spcPts val="100"/>
+              </a:spcBef>
+            </a:pPr>
+            <a:r>
+              <a:rPr lang="en-US" sz="1400" b="1" dirty="0"/>
+              <a:t>Pipeline A: </a:t>
+            </a:r>
+            <a:r>
+              <a:rPr lang="en-US" sz="1400" dirty="0"/>
+              <a:t>rv = obj.config[...] — mid-method fragment. No class definition or __init__ visible.</a:t>
+            </a:r>
+          </a:p>
+          <a:p>
+            <a:pPr algn="l">
+              <a:spcBef>
+                <a:spcPts val="100"/>
+              </a:spcBef>
+            </a:pPr>
+            <a:r>
+              <a:rPr lang="en-US" sz="1400" b="1" dirty="0">
+                <a:solidFill>
+                  <a:srgbClr val="227722"/>
+                </a:solidFill>
+              </a:rPr>
+              <a:t>Pipeline B: </a:t>
+            </a:r>
+            <a:r>
+              <a:rPr lang="en-US" sz="1400" dirty="0"/>
+              <a:t>class ConfigAttribute(t.Generic[T]): with complete __init__ and all property descriptors.</a:t>
+            </a:r>
           </a:p>
         </p:txBody>
       </p:sp>

</xml_diff>